<commit_message>
docs: executive deck - the UK LGA's agentic AI playbook on the closing slide
"Agentic AI is not primarily a technology challenge" (LGA, October 2026);
the notes add that adoption depends on data maturity, process clarity and
leadership discipline - the same conclusion the corpus reached.
</commit_message>
<xml_diff>
--- a/docs/ceo-deck/Getting our filings ready for AI.pptx
+++ b/docs/ceo-deck/Getting our filings ready for AI.pptx
@@ -118,14 +118,14 @@
   <p:extLst>
     <p:ext uri="{521415D9-36F7-43E2-AB2F-B90AF26B5E84}">
       <p14:sectionLst xmlns:p14="http://schemas.microsoft.com/office/powerpoint/2010/main">
-        <p14:section name="The record" id="{e8b4385b-f3ab-71ad-6476-b05818c06270}">
+        <p14:section name="The record" id="{22c158b1-4c91-75b6-b001-30895f459a6b}">
           <p14:sldIdLst>
             <p14:sldId id="256"/>
             <p14:sldId id="257"/>
             <p14:sldId id="258"/>
           </p14:sldIdLst>
         </p14:section>
-        <p14:section name="The problems" id="{c40cbb1f-57db-1144-ab48-e7278e369c97}">
+        <p14:section name="The problems" id="{6e93f080-5a12-3c80-28e7-1bf88e47637f}">
           <p14:sldIdLst>
             <p14:sldId id="259"/>
             <p14:sldId id="260"/>
@@ -134,14 +134,14 @@
             <p14:sldId id="263"/>
           </p14:sldIdLst>
         </p14:section>
-        <p14:section name="The solution" id="{b9db8805-b872-e29d-9e43-9315eaef87f8}">
+        <p14:section name="The solution" id="{9e0fd384-9063-cacc-8af3-905d85a77f78}">
           <p14:sldIdLst>
             <p14:sldId id="264"/>
             <p14:sldId id="265"/>
             <p14:sldId id="266"/>
           </p14:sldIdLst>
         </p14:section>
-        <p14:section name="Making change happen" id="{3d40badb-5c15-a5d7-85c8-fdb5485bb927}">
+        <p14:section name="Making change happen" id="{9e72e299-1103-6b68-245d-dd3170333f89}">
           <p14:sldIdLst>
             <p14:sldId id="267"/>
           </p14:sldIdLst>
@@ -814,7 +814,7 @@
           <a:p>
             <a:r>
               <a:rPr lang="en-US" dirty="0"/>
-              <a:t>These lessons apply well beyond filings. AI is only as good as its data, so fix data where it is created. Failures are silent - a system can look finished and still be wrong, so ask for proof. Rules beat advice - build checks into systems rather than writing more guidance. And small habits add up - printing documents just to sign them created nearly half of this problem. What we are asking for: stand up an AI build team and a cloud strategy with an executive sponsor; change our filing rules and portal through the Rules of Practice review that is already under way; and start now with two quick wins - the automatic upload check, and a privacy review of the documents whose redactions do not hide anything.</a:t>
+              <a:t>These lessons apply well beyond filings. AI is only as good as its data, so fix data where it is created. Failures are silent - a system can look finished and still be wrong, so ask for proof. Rules beat advice - build checks into systems rather than writing more guidance. And small habits add up - printing documents just to sign them created nearly half of this problem. What we are asking for: stand up an AI build team and a cloud strategy with an executive sponsor; change our filing rules and portal through the Rules of Practice review that is already under way; and start now with two quick wins - the automatic upload check, and a privacy review of the documents whose redactions do not hide anything. Others have reached the same conclusion: the UK Local Government Association's playbook for agentic AI (October 2026) says agentic AI is not primarily a technology challenge, and that adoption depends on data maturity, process clarity and leadership discipline as much as on technical capability.</a:t>
             </a:r>
             <a:endParaRPr lang="en-US" dirty="0"/>
           </a:p>
@@ -4663,6 +4663,42 @@
               <a:t>Start now with two quick wins: the automatic upload check, and a privacy review of flawed redactions</a:t>
             </a:r>
             <a:endParaRPr lang="en-US" sz="1700" dirty="0"/>
+          </a:p>
+        </p:txBody>
+      </p:sp>
+      <p:sp>
+        <p:nvSpPr>
+          <p:cNvPr id="14" name="Text 12"/>
+          <p:cNvSpPr txBox="1"/>
+          <p:nvPr/>
+        </p:nvSpPr>
+        <p:spPr>
+          <a:xfrm>
+            <a:off x="548640" y="6263640"/>
+            <a:ext cx="10424160" cy="365760"/>
+          </a:xfrm>
+          <a:prstGeom prst="rect">
+            <a:avLst/>
+          </a:prstGeom>
+          <a:noFill/>
+          <a:ln/>
+        </p:spPr>
+        <p:txBody>
+          <a:bodyPr wrap="square" lIns="0" tIns="0" rIns="0" bIns="0" rtlCol="0" anchor="ctr"/>
+          <a:lstStyle/>
+          <a:p>
+            <a:pPr indent="0" marL="0">
+              <a:buNone/>
+            </a:pPr>
+            <a:r>
+              <a:rPr lang="en-US" sz="1200" i="1" dirty="0">
+                <a:solidFill>
+                  <a:schemeClr val="bg2"/>
+                </a:solidFill>
+              </a:rPr>
+              <a:t>“Agentic AI is not primarily a technology challenge.”  — UK Local Government Association, 2026</a:t>
+            </a:r>
+            <a:endParaRPr lang="en-US" sz="1200" dirty="0"/>
           </a:p>
         </p:txBody>
       </p:sp>

</xml_diff>

<commit_message>
docs: executive deck - start small, scale with care (UK LGA agentic AI playbook)
A new slide from the LGA's playbook (9 Oct 2026): three tiers of risk
(personal, team, organisation) with governance to match, and managing AI
like a new employee (a job description, a trial period, performance
reviews, a way to switch it off), training at every level. The finding
slide quotes it: AI will not fix unclear processes, weak ownership or
poor-quality data; it makes those weaknesses more visible. 13 slides.
</commit_message>
<xml_diff>
--- a/docs/ceo-deck/Getting our filings ready for AI.pptx
+++ b/docs/ceo-deck/Getting our filings ready for AI.pptx
@@ -17,9 +17,10 @@
     <p:sldId id="265" r:id="rId11"/>
     <p:sldId id="266" r:id="rId12"/>
     <p:sldId id="267" r:id="rId13"/>
+    <p:sldId id="268" r:id="rId14"/>
   </p:sldIdLst>
   <p:notesMasterIdLst>
-    <p:notesMasterId r:id="rId14"/>
+    <p:notesMasterId r:id="rId15"/>
   </p:notesMasterIdLst>
   <p:sldSz cx="12192000" cy="6858000"/>
   <p:notesSz cx="6858000" cy="12192000"/>
@@ -118,14 +119,14 @@
   <p:extLst>
     <p:ext uri="{521415D9-36F7-43E2-AB2F-B90AF26B5E84}">
       <p14:sectionLst xmlns:p14="http://schemas.microsoft.com/office/powerpoint/2010/main">
-        <p14:section name="The record" id="{22c158b1-4c91-75b6-b001-30895f459a6b}">
+        <p14:section name="The record" id="{a197ede7-47a3-55fe-98ef-ac215573e20d}">
           <p14:sldIdLst>
             <p14:sldId id="256"/>
             <p14:sldId id="257"/>
             <p14:sldId id="258"/>
           </p14:sldIdLst>
         </p14:section>
-        <p14:section name="The problems" id="{6e93f080-5a12-3c80-28e7-1bf88e47637f}">
+        <p14:section name="The problems" id="{d85d5ecd-789f-e77b-3b01-c35fd32a82ec}">
           <p14:sldIdLst>
             <p14:sldId id="259"/>
             <p14:sldId id="260"/>
@@ -134,16 +135,17 @@
             <p14:sldId id="263"/>
           </p14:sldIdLst>
         </p14:section>
-        <p14:section name="The solution" id="{9e0fd384-9063-cacc-8af3-905d85a77f78}">
+        <p14:section name="The solution" id="{3a02df9b-f853-01bf-7581-4ce91f1a5b81}">
           <p14:sldIdLst>
             <p14:sldId id="264"/>
             <p14:sldId id="265"/>
             <p14:sldId id="266"/>
+            <p14:sldId id="267"/>
           </p14:sldIdLst>
         </p14:section>
-        <p14:section name="Making change happen" id="{9e72e299-1103-6b68-245d-dd3170333f89}">
+        <p14:section name="Making change happen" id="{0d751de8-63fd-82d1-4f45-ab9c56eb515b}">
           <p14:sldIdLst>
-            <p14:sldId id="267"/>
+            <p14:sldId id="268"/>
           </p14:sldIdLst>
         </p14:section>
       </p14:sectionLst>
@@ -814,7 +816,7 @@
           <a:p>
             <a:r>
               <a:rPr lang="en-US" dirty="0"/>
-              <a:t>These lessons apply well beyond filings. AI is only as good as its data, so fix data where it is created. Failures are silent - a system can look finished and still be wrong, so ask for proof. Rules beat advice - build checks into systems rather than writing more guidance. And small habits add up - printing documents just to sign them created nearly half of this problem. What we are asking for: stand up an AI build team and a cloud strategy with an executive sponsor; change our filing rules and portal through the Rules of Practice review that is already under way; and start now with two quick wins - the automatic upload check, and a privacy review of the documents whose redactions do not hide anything. Others have reached the same conclusion: the UK Local Government Association's playbook for agentic AI (October 2026) says agentic AI is not primarily a technology challenge, and that adoption depends on data maturity, process clarity and leadership discipline as much as on technical capability.</a:t>
+              <a:t>How to start safely, drawing on the UK Local Government Association's playbook for agentic AI (October 2026), written with councils and endorsed by the LGA. Scale governance with risk, in three tiers. Tier one is personal use - drafting and summarising - low risk, covered by staff guidance. Tier two is team use - knowledge assistants and triage within a service - with a named service owner and central oversight. Tier three is organisation-wide, public-facing or decision support, which needs formal approval and assurance. And manage each AI tool like a new employee: a job description that sets its task, data and limits; a trial period before full roll-out; performance reviews; and the ability to switch it off, with a person always accountable. Train every level - all staff to use AI safely, team leads to build it into their work, and executives to weigh risk and value. The playbook's cyber-security guidance was co-written with the Canadian Centre for Cyber Security.</a:t>
             </a:r>
             <a:endParaRPr lang="en-US" dirty="0"/>
           </a:p>
@@ -838,6 +840,94 @@
             <a:fld id="{F7021451-1387-4CA6-816F-3879F97B5CBC}" type="slidenum">
               <a:rPr lang="en-US"/>
               <a:t>12</a:t>
+            </a:fld>
+            <a:endParaRPr lang="en-US"/>
+          </a:p>
+        </p:txBody>
+      </p:sp>
+    </p:spTree>
+    <p:extLst>
+      <p:ext uri="{BB962C8B-B14F-4D97-AF65-F5344CB8AC3E}">
+        <p14:creationId xmlns:p14="http://schemas.microsoft.com/office/powerpoint/2010/main" val="1024086991"/>
+      </p:ext>
+    </p:extLst>
+  </p:cSld>
+  <p:clrMapOvr>
+    <a:masterClrMapping/>
+  </p:clrMapOvr>
+</p:notes>
+</file>
+
+<file path=ppt/notesSlides/notesSlide13.xml><?xml version="1.0" encoding="utf-8"?>
+<p:notes xmlns:a="http://schemas.openxmlformats.org/drawingml/2006/main" xmlns:r="http://schemas.openxmlformats.org/officeDocument/2006/relationships" xmlns:p="http://schemas.openxmlformats.org/presentationml/2006/main">
+  <p:cSld>
+    <p:spTree>
+      <p:nvGrpSpPr>
+        <p:cNvPr id="1" name=""/>
+        <p:cNvGrpSpPr/>
+        <p:nvPr/>
+      </p:nvGrpSpPr>
+      <p:grpSpPr>
+        <a:xfrm>
+          <a:off x="0" y="0"/>
+          <a:ext cx="0" cy="0"/>
+          <a:chOff x="0" y="0"/>
+          <a:chExt cx="0" cy="0"/>
+        </a:xfrm>
+      </p:grpSpPr>
+      <p:sp>
+        <p:nvSpPr>
+          <p:cNvPr id="2" name="Slide Image Placeholder 1"/>
+          <p:cNvSpPr>
+            <a:spLocks noGrp="1" noRot="1" noChangeAspect="1"/>
+          </p:cNvSpPr>
+          <p:nvPr>
+            <p:ph type="sldImg"/>
+          </p:nvPr>
+        </p:nvSpPr>
+        <p:spPr/>
+      </p:sp>
+      <p:sp>
+        <p:nvSpPr>
+          <p:cNvPr id="3" name="Notes Placeholder 2"/>
+          <p:cNvSpPr>
+            <a:spLocks noGrp="1"/>
+          </p:cNvSpPr>
+          <p:nvPr>
+            <p:ph type="body" idx="1"/>
+          </p:nvPr>
+        </p:nvSpPr>
+        <p:spPr/>
+        <p:txBody>
+          <a:bodyPr/>
+          <a:lstStyle/>
+          <a:p>
+            <a:r>
+              <a:rPr lang="en-US" dirty="0"/>
+              <a:t>These lessons apply well beyond filings. AI is only as good as its data, so fix data where it is created. Failures are silent - a system can look finished and still be wrong, so ask for proof. Rules beat advice - build checks into systems rather than writing more guidance. And small habits add up - printing documents just to sign them created nearly half of this problem. What we are asking for: stand up an AI build team and a cloud strategy with an executive sponsor; change our filing rules and portal through the Rules of Practice review that is already under way; and start now with two quick wins - the automatic upload check, and a privacy review of the documents whose redactions do not hide anything. Others have reached the same conclusion: the UK Local Government Association's playbook for agentic AI (October 2026) says agentic AI is not primarily a technology challenge, and that adoption depends on data maturity, process clarity and leadership discipline as much as on technical capability.</a:t>
+            </a:r>
+            <a:endParaRPr lang="en-US" dirty="0"/>
+          </a:p>
+        </p:txBody>
+      </p:sp>
+      <p:sp>
+        <p:nvSpPr>
+          <p:cNvPr id="4" name="Slide Number Placeholder 3"/>
+          <p:cNvSpPr>
+            <a:spLocks noGrp="1"/>
+          </p:cNvSpPr>
+          <p:nvPr>
+            <p:ph type="sldNum" sz="quarter" idx="10"/>
+          </p:nvPr>
+        </p:nvSpPr>
+        <p:spPr/>
+        <p:txBody>
+          <a:bodyPr/>
+          <a:lstStyle/>
+          <a:p>
+            <a:fld id="{F7021451-1387-4CA6-816F-3879F97B5CBC}" type="slidenum">
+              <a:rPr lang="en-US"/>
+              <a:t>13</a:t>
             </a:fld>
             <a:endParaRPr lang="en-US"/>
           </a:p>
@@ -1078,7 +1168,7 @@
           <a:p>
             <a:r>
               <a:rPr lang="en-US" dirty="0"/>
-              <a:t>Here is the headline. About one document in four in our record cannot be read reliably by a computer. Any AI tool we put on top of this record - search, summaries, assistants for reviewers - can only be as good as what it reads. For a quarter of the record, it would be guessing at pictures of pages, or reading text that is simply wrong.</a:t>
+              <a:t>Here is the headline. About one document in four in our record cannot be read reliably by a computer. Any AI tool we put on top of this record - search, summaries, assistants for reviewers - can only be as good as what it reads. For a quarter of the record, it would be guessing at pictures of pages, or reading text that is simply wrong. The UK Local Government Association put it well in its October 2026 playbook for agentic AI: AI will not fix unclear processes, weak ownership or poor-quality data - in many cases it will make those weaknesses more visible.</a:t>
             </a:r>
             <a:endParaRPr lang="en-US" dirty="0"/>
           </a:p>
@@ -4235,10 +4325,10 @@
             <a:r>
               <a:rPr lang="en-US" sz="3400" b="1" dirty="0">
                 <a:solidFill>
-                  <a:schemeClr val="bg1"/>
-                </a:solidFill>
-              </a:rPr>
-              <a:t>Lessons for every part of the organization</a:t>
+                  <a:schemeClr val="tx2"/>
+                </a:solidFill>
+              </a:rPr>
+              <a:t>Start small, scale with care</a:t>
             </a:r>
             <a:endParaRPr lang="en-US" sz="3400" dirty="0"/>
           </a:p>
@@ -4246,324 +4336,316 @@
       </p:sp>
       <p:sp>
         <p:nvSpPr>
-          <p:cNvPr id="3" name="Text 1"/>
-          <p:cNvSpPr txBox="1"/>
-          <p:nvPr/>
-        </p:nvSpPr>
-        <p:spPr>
-          <a:xfrm>
-            <a:off x="548640" y="1417320"/>
-            <a:ext cx="5394960" cy="502920"/>
-          </a:xfrm>
-          <a:prstGeom prst="rect">
-            <a:avLst/>
-          </a:prstGeom>
-          <a:noFill/>
-          <a:ln/>
-        </p:spPr>
-        <p:txBody>
-          <a:bodyPr wrap="square" lIns="0" tIns="0" rIns="0" bIns="0" rtlCol="0" anchor="ctr"/>
-          <a:lstStyle/>
-          <a:p>
-            <a:pPr indent="0" marL="0">
-              <a:buNone/>
-            </a:pPr>
-            <a:r>
-              <a:rPr lang="en-US" sz="2100" b="1" dirty="0">
-                <a:solidFill>
-                  <a:schemeClr val="accent1"/>
-                </a:solidFill>
-              </a:rPr>
-              <a:t>AI is only as good as its data</a:t>
-            </a:r>
-            <a:endParaRPr lang="en-US" sz="2100" dirty="0"/>
-          </a:p>
-        </p:txBody>
-      </p:sp>
-      <p:sp>
-        <p:nvSpPr>
-          <p:cNvPr id="4" name="Text 2"/>
-          <p:cNvSpPr txBox="1"/>
-          <p:nvPr/>
-        </p:nvSpPr>
-        <p:spPr>
-          <a:xfrm>
-            <a:off x="548640" y="1920240"/>
-            <a:ext cx="5394960" cy="548640"/>
-          </a:xfrm>
-          <a:prstGeom prst="rect">
-            <a:avLst/>
-          </a:prstGeom>
-          <a:noFill/>
-          <a:ln/>
-        </p:spPr>
-        <p:txBody>
-          <a:bodyPr wrap="square" lIns="0" tIns="0" rIns="0" bIns="0" rtlCol="0" anchor="t"/>
-          <a:lstStyle/>
-          <a:p>
-            <a:pPr indent="0" marL="0">
-              <a:buNone/>
-            </a:pPr>
-            <a:r>
-              <a:rPr lang="en-US" sz="1600" dirty="0">
-                <a:solidFill>
-                  <a:schemeClr val="bg2"/>
-                </a:solidFill>
-              </a:rPr>
-              <a:t>Fix data where it is created, not after.</a:t>
-            </a:r>
-            <a:endParaRPr lang="en-US" sz="1600" dirty="0"/>
-          </a:p>
-        </p:txBody>
-      </p:sp>
-      <p:sp>
-        <p:nvSpPr>
-          <p:cNvPr id="5" name="Text 3"/>
-          <p:cNvSpPr txBox="1"/>
-          <p:nvPr/>
-        </p:nvSpPr>
-        <p:spPr>
-          <a:xfrm>
-            <a:off x="6217920" y="1417320"/>
-            <a:ext cx="5394960" cy="502920"/>
-          </a:xfrm>
-          <a:prstGeom prst="rect">
-            <a:avLst/>
-          </a:prstGeom>
-          <a:noFill/>
-          <a:ln/>
-        </p:spPr>
-        <p:txBody>
-          <a:bodyPr wrap="square" lIns="0" tIns="0" rIns="0" bIns="0" rtlCol="0" anchor="ctr"/>
-          <a:lstStyle/>
-          <a:p>
-            <a:pPr indent="0" marL="0">
-              <a:buNone/>
-            </a:pPr>
-            <a:r>
-              <a:rPr lang="en-US" sz="2100" b="1" dirty="0">
-                <a:solidFill>
-                  <a:schemeClr val="accent1"/>
-                </a:solidFill>
-              </a:rPr>
-              <a:t>Failures are silent</a:t>
-            </a:r>
-            <a:endParaRPr lang="en-US" sz="2100" dirty="0"/>
-          </a:p>
-        </p:txBody>
-      </p:sp>
-      <p:sp>
-        <p:nvSpPr>
-          <p:cNvPr id="6" name="Text 4"/>
-          <p:cNvSpPr txBox="1"/>
-          <p:nvPr/>
-        </p:nvSpPr>
-        <p:spPr>
-          <a:xfrm>
-            <a:off x="6217920" y="1920240"/>
-            <a:ext cx="5394960" cy="548640"/>
-          </a:xfrm>
-          <a:prstGeom prst="rect">
-            <a:avLst/>
-          </a:prstGeom>
-          <a:noFill/>
-          <a:ln/>
-        </p:spPr>
-        <p:txBody>
-          <a:bodyPr wrap="square" lIns="0" tIns="0" rIns="0" bIns="0" rtlCol="0" anchor="t"/>
-          <a:lstStyle/>
-          <a:p>
-            <a:pPr indent="0" marL="0">
-              <a:buNone/>
-            </a:pPr>
-            <a:r>
-              <a:rPr lang="en-US" sz="1600" dirty="0">
-                <a:solidFill>
-                  <a:schemeClr val="bg2"/>
-                </a:solidFill>
-              </a:rPr>
-              <a:t>A system can look finished and be wrong. Ask for proof.</a:t>
-            </a:r>
-            <a:endParaRPr lang="en-US" sz="1600" dirty="0"/>
-          </a:p>
-        </p:txBody>
-      </p:sp>
-      <p:sp>
-        <p:nvSpPr>
-          <p:cNvPr id="7" name="Text 5"/>
-          <p:cNvSpPr txBox="1"/>
-          <p:nvPr/>
-        </p:nvSpPr>
-        <p:spPr>
-          <a:xfrm>
-            <a:off x="548640" y="2651760"/>
-            <a:ext cx="5394960" cy="502920"/>
-          </a:xfrm>
-          <a:prstGeom prst="rect">
-            <a:avLst/>
-          </a:prstGeom>
-          <a:noFill/>
-          <a:ln/>
-        </p:spPr>
-        <p:txBody>
-          <a:bodyPr wrap="square" lIns="0" tIns="0" rIns="0" bIns="0" rtlCol="0" anchor="ctr"/>
-          <a:lstStyle/>
-          <a:p>
-            <a:pPr indent="0" marL="0">
-              <a:buNone/>
-            </a:pPr>
-            <a:r>
-              <a:rPr lang="en-US" sz="2100" b="1" dirty="0">
-                <a:solidFill>
-                  <a:schemeClr val="accent1"/>
-                </a:solidFill>
-              </a:rPr>
-              <a:t>Rules beat advice</a:t>
-            </a:r>
-            <a:endParaRPr lang="en-US" sz="2100" dirty="0"/>
-          </a:p>
-        </p:txBody>
-      </p:sp>
-      <p:sp>
-        <p:nvSpPr>
-          <p:cNvPr id="8" name="Text 6"/>
-          <p:cNvSpPr txBox="1"/>
-          <p:nvPr/>
-        </p:nvSpPr>
-        <p:spPr>
-          <a:xfrm>
-            <a:off x="548640" y="3154680"/>
-            <a:ext cx="5394960" cy="548640"/>
-          </a:xfrm>
-          <a:prstGeom prst="rect">
-            <a:avLst/>
-          </a:prstGeom>
-          <a:noFill/>
-          <a:ln/>
-        </p:spPr>
-        <p:txBody>
-          <a:bodyPr wrap="square" lIns="0" tIns="0" rIns="0" bIns="0" rtlCol="0" anchor="t"/>
-          <a:lstStyle/>
-          <a:p>
-            <a:pPr indent="0" marL="0">
-              <a:buNone/>
-            </a:pPr>
-            <a:r>
-              <a:rPr lang="en-US" sz="1600" dirty="0">
-                <a:solidFill>
-                  <a:schemeClr val="bg2"/>
-                </a:solidFill>
-              </a:rPr>
-              <a:t>Build checks into systems instead of writing guidance.</a:t>
-            </a:r>
-            <a:endParaRPr lang="en-US" sz="1600" dirty="0"/>
-          </a:p>
-        </p:txBody>
-      </p:sp>
-      <p:sp>
-        <p:nvSpPr>
-          <p:cNvPr id="9" name="Text 7"/>
-          <p:cNvSpPr txBox="1"/>
-          <p:nvPr/>
-        </p:nvSpPr>
-        <p:spPr>
-          <a:xfrm>
-            <a:off x="6217920" y="2651760"/>
-            <a:ext cx="5394960" cy="502920"/>
-          </a:xfrm>
-          <a:prstGeom prst="rect">
-            <a:avLst/>
-          </a:prstGeom>
-          <a:noFill/>
-          <a:ln/>
-        </p:spPr>
-        <p:txBody>
-          <a:bodyPr wrap="square" lIns="0" tIns="0" rIns="0" bIns="0" rtlCol="0" anchor="ctr"/>
-          <a:lstStyle/>
-          <a:p>
-            <a:pPr indent="0" marL="0">
-              <a:buNone/>
-            </a:pPr>
-            <a:r>
-              <a:rPr lang="en-US" sz="2100" b="1" dirty="0">
-                <a:solidFill>
-                  <a:schemeClr val="accent1"/>
-                </a:solidFill>
-              </a:rPr>
-              <a:t>Small habits add up</a:t>
-            </a:r>
-            <a:endParaRPr lang="en-US" sz="2100" dirty="0"/>
-          </a:p>
-        </p:txBody>
-      </p:sp>
-      <p:sp>
-        <p:nvSpPr>
-          <p:cNvPr id="10" name="Text 8"/>
-          <p:cNvSpPr txBox="1"/>
-          <p:nvPr/>
-        </p:nvSpPr>
-        <p:spPr>
-          <a:xfrm>
-            <a:off x="6217920" y="3154680"/>
-            <a:ext cx="5394960" cy="548640"/>
-          </a:xfrm>
-          <a:prstGeom prst="rect">
-            <a:avLst/>
-          </a:prstGeom>
-          <a:noFill/>
-          <a:ln/>
-        </p:spPr>
-        <p:txBody>
-          <a:bodyPr wrap="square" lIns="0" tIns="0" rIns="0" bIns="0" rtlCol="0" anchor="t"/>
-          <a:lstStyle/>
-          <a:p>
-            <a:pPr indent="0" marL="0">
-              <a:buNone/>
-            </a:pPr>
-            <a:r>
-              <a:rPr lang="en-US" sz="1600" dirty="0">
-                <a:solidFill>
-                  <a:schemeClr val="bg2"/>
-                </a:solidFill>
-              </a:rPr>
-              <a:t>Printing to sign made nearly half the problem.</a:t>
-            </a:r>
-            <a:endParaRPr lang="en-US" sz="1600" dirty="0"/>
-          </a:p>
-        </p:txBody>
-      </p:sp>
-      <p:sp>
-        <p:nvSpPr>
-          <p:cNvPr id="11" name="Shape 9"/>
+          <p:cNvPr id="3" name="Shape 1"/>
           <p:cNvSpPr/>
           <p:nvPr/>
         </p:nvSpPr>
         <p:spPr>
           <a:xfrm>
-            <a:off x="548640" y="3977640"/>
-            <a:ext cx="11064240" cy="2194560"/>
+            <a:off x="548640" y="1463040"/>
+            <a:ext cx="6035040" cy="1280160"/>
           </a:xfrm>
           <a:prstGeom prst="roundRect">
             <a:avLst>
-              <a:gd name="adj" fmla="val 6250"/>
+              <a:gd name="adj" fmla="val 10714"/>
             </a:avLst>
           </a:prstGeom>
           <a:solidFill>
-            <a:schemeClr val="bg1"/>
+            <a:schemeClr val="bg2"/>
           </a:solidFill>
           <a:ln/>
         </p:spPr>
       </p:sp>
       <p:sp>
         <p:nvSpPr>
+          <p:cNvPr id="4" name="Text 2"/>
+          <p:cNvSpPr txBox="1"/>
+          <p:nvPr/>
+        </p:nvSpPr>
+        <p:spPr>
+          <a:xfrm>
+            <a:off x="777240" y="1645920"/>
+            <a:ext cx="548640" cy="914400"/>
+          </a:xfrm>
+          <a:prstGeom prst="rect">
+            <a:avLst/>
+          </a:prstGeom>
+          <a:noFill/>
+          <a:ln/>
+        </p:spPr>
+        <p:txBody>
+          <a:bodyPr wrap="square" lIns="0" tIns="0" rIns="0" bIns="0" rtlCol="0" anchor="ctr"/>
+          <a:lstStyle/>
+          <a:p>
+            <a:pPr indent="0" marL="0">
+              <a:buNone/>
+            </a:pPr>
+            <a:r>
+              <a:rPr lang="en-US" sz="4000" b="1" dirty="0">
+                <a:solidFill>
+                  <a:schemeClr val="accent1"/>
+                </a:solidFill>
+                <a:latin typeface="Cambria" pitchFamily="34" charset="0"/>
+                <a:ea typeface="Cambria" pitchFamily="34" charset="-122"/>
+                <a:cs typeface="Cambria" pitchFamily="34" charset="-120"/>
+              </a:rPr>
+              <a:t>1</a:t>
+            </a:r>
+            <a:endParaRPr lang="en-US" sz="4000" dirty="0"/>
+          </a:p>
+        </p:txBody>
+      </p:sp>
+      <p:sp>
+        <p:nvSpPr>
+          <p:cNvPr id="5" name="Text 3"/>
+          <p:cNvSpPr txBox="1"/>
+          <p:nvPr/>
+        </p:nvSpPr>
+        <p:spPr>
+          <a:xfrm>
+            <a:off x="1463040" y="1600200"/>
+            <a:ext cx="4480560" cy="457200"/>
+          </a:xfrm>
+          <a:prstGeom prst="rect">
+            <a:avLst/>
+          </a:prstGeom>
+          <a:noFill/>
+          <a:ln/>
+        </p:spPr>
+        <p:txBody>
+          <a:bodyPr wrap="square" lIns="0" tIns="0" rIns="0" bIns="0" rtlCol="0" anchor="ctr"/>
+          <a:lstStyle/>
+          <a:p>
+            <a:pPr indent="0" marL="0">
+              <a:buNone/>
+            </a:pPr>
+            <a:r>
+              <a:rPr lang="en-US" sz="2000" b="1" dirty="0">
+                <a:solidFill>
+                  <a:schemeClr val="tx2"/>
+                </a:solidFill>
+              </a:rPr>
+              <a:t>Personal</a:t>
+            </a:r>
+            <a:endParaRPr lang="en-US" sz="2000" dirty="0"/>
+          </a:p>
+        </p:txBody>
+      </p:sp>
+      <p:sp>
+        <p:nvSpPr>
+          <p:cNvPr id="6" name="Text 4"/>
+          <p:cNvSpPr txBox="1"/>
+          <p:nvPr/>
+        </p:nvSpPr>
+        <p:spPr>
+          <a:xfrm>
+            <a:off x="1463040" y="2029968"/>
+            <a:ext cx="4846320" cy="320040"/>
+          </a:xfrm>
+          <a:prstGeom prst="rect">
+            <a:avLst/>
+          </a:prstGeom>
+          <a:noFill/>
+          <a:ln/>
+        </p:spPr>
+        <p:txBody>
+          <a:bodyPr wrap="square" lIns="0" tIns="0" rIns="0" bIns="0" rtlCol="0" anchor="ctr"/>
+          <a:lstStyle/>
+          <a:p>
+            <a:pPr indent="0" marL="0">
+              <a:buNone/>
+            </a:pPr>
+            <a:r>
+              <a:rPr lang="en-US" sz="1500" dirty="0">
+                <a:solidFill>
+                  <a:schemeClr val="tx1"/>
+                </a:solidFill>
+              </a:rPr>
+              <a:t>Drafting, summarising</a:t>
+            </a:r>
+            <a:endParaRPr lang="en-US" sz="1500" dirty="0"/>
+          </a:p>
+        </p:txBody>
+      </p:sp>
+      <p:sp>
+        <p:nvSpPr>
+          <p:cNvPr id="7" name="Text 5"/>
+          <p:cNvSpPr txBox="1"/>
+          <p:nvPr/>
+        </p:nvSpPr>
+        <p:spPr>
+          <a:xfrm>
+            <a:off x="1463040" y="2331720"/>
+            <a:ext cx="4846320" cy="320040"/>
+          </a:xfrm>
+          <a:prstGeom prst="rect">
+            <a:avLst/>
+          </a:prstGeom>
+          <a:noFill/>
+          <a:ln/>
+        </p:spPr>
+        <p:txBody>
+          <a:bodyPr wrap="square" lIns="0" tIns="0" rIns="0" bIns="0" rtlCol="0" anchor="ctr"/>
+          <a:lstStyle/>
+          <a:p>
+            <a:pPr indent="0" marL="0">
+              <a:buNone/>
+            </a:pPr>
+            <a:r>
+              <a:rPr lang="en-US" sz="1300" i="1" dirty="0">
+                <a:solidFill>
+                  <a:schemeClr val="accent3"/>
+                </a:solidFill>
+              </a:rPr>
+              <a:t>Low risk: staff guidance</a:t>
+            </a:r>
+            <a:endParaRPr lang="en-US" sz="1300" dirty="0"/>
+          </a:p>
+        </p:txBody>
+      </p:sp>
+      <p:sp>
+        <p:nvSpPr>
+          <p:cNvPr id="8" name="Shape 6"/>
+          <p:cNvSpPr/>
+          <p:nvPr/>
+        </p:nvSpPr>
+        <p:spPr>
+          <a:xfrm>
+            <a:off x="960120" y="2926080"/>
+            <a:ext cx="5623560" cy="1280160"/>
+          </a:xfrm>
+          <a:prstGeom prst="roundRect">
+            <a:avLst>
+              <a:gd name="adj" fmla="val 10714"/>
+            </a:avLst>
+          </a:prstGeom>
+          <a:solidFill>
+            <a:schemeClr val="bg2"/>
+          </a:solidFill>
+          <a:ln/>
+        </p:spPr>
+      </p:sp>
+      <p:sp>
+        <p:nvSpPr>
+          <p:cNvPr id="9" name="Text 7"/>
+          <p:cNvSpPr txBox="1"/>
+          <p:nvPr/>
+        </p:nvSpPr>
+        <p:spPr>
+          <a:xfrm>
+            <a:off x="1188720" y="3108960"/>
+            <a:ext cx="548640" cy="914400"/>
+          </a:xfrm>
+          <a:prstGeom prst="rect">
+            <a:avLst/>
+          </a:prstGeom>
+          <a:noFill/>
+          <a:ln/>
+        </p:spPr>
+        <p:txBody>
+          <a:bodyPr wrap="square" lIns="0" tIns="0" rIns="0" bIns="0" rtlCol="0" anchor="ctr"/>
+          <a:lstStyle/>
+          <a:p>
+            <a:pPr indent="0" marL="0">
+              <a:buNone/>
+            </a:pPr>
+            <a:r>
+              <a:rPr lang="en-US" sz="4000" b="1" dirty="0">
+                <a:solidFill>
+                  <a:schemeClr val="accent1"/>
+                </a:solidFill>
+                <a:latin typeface="Cambria" pitchFamily="34" charset="0"/>
+                <a:ea typeface="Cambria" pitchFamily="34" charset="-122"/>
+                <a:cs typeface="Cambria" pitchFamily="34" charset="-120"/>
+              </a:rPr>
+              <a:t>2</a:t>
+            </a:r>
+            <a:endParaRPr lang="en-US" sz="4000" dirty="0"/>
+          </a:p>
+        </p:txBody>
+      </p:sp>
+      <p:sp>
+        <p:nvSpPr>
+          <p:cNvPr id="10" name="Text 8"/>
+          <p:cNvSpPr txBox="1"/>
+          <p:nvPr/>
+        </p:nvSpPr>
+        <p:spPr>
+          <a:xfrm>
+            <a:off x="1874520" y="3063240"/>
+            <a:ext cx="4069080" cy="457200"/>
+          </a:xfrm>
+          <a:prstGeom prst="rect">
+            <a:avLst/>
+          </a:prstGeom>
+          <a:noFill/>
+          <a:ln/>
+        </p:spPr>
+        <p:txBody>
+          <a:bodyPr wrap="square" lIns="0" tIns="0" rIns="0" bIns="0" rtlCol="0" anchor="ctr"/>
+          <a:lstStyle/>
+          <a:p>
+            <a:pPr indent="0" marL="0">
+              <a:buNone/>
+            </a:pPr>
+            <a:r>
+              <a:rPr lang="en-US" sz="2000" b="1" dirty="0">
+                <a:solidFill>
+                  <a:schemeClr val="tx2"/>
+                </a:solidFill>
+              </a:rPr>
+              <a:t>Team</a:t>
+            </a:r>
+            <a:endParaRPr lang="en-US" sz="2000" dirty="0"/>
+          </a:p>
+        </p:txBody>
+      </p:sp>
+      <p:sp>
+        <p:nvSpPr>
+          <p:cNvPr id="11" name="Text 9"/>
+          <p:cNvSpPr txBox="1"/>
+          <p:nvPr/>
+        </p:nvSpPr>
+        <p:spPr>
+          <a:xfrm>
+            <a:off x="1874520" y="3493008"/>
+            <a:ext cx="4434840" cy="320040"/>
+          </a:xfrm>
+          <a:prstGeom prst="rect">
+            <a:avLst/>
+          </a:prstGeom>
+          <a:noFill/>
+          <a:ln/>
+        </p:spPr>
+        <p:txBody>
+          <a:bodyPr wrap="square" lIns="0" tIns="0" rIns="0" bIns="0" rtlCol="0" anchor="ctr"/>
+          <a:lstStyle/>
+          <a:p>
+            <a:pPr indent="0" marL="0">
+              <a:buNone/>
+            </a:pPr>
+            <a:r>
+              <a:rPr lang="en-US" sz="1500" dirty="0">
+                <a:solidFill>
+                  <a:schemeClr val="tx1"/>
+                </a:solidFill>
+              </a:rPr>
+              <a:t>Knowledge assistants, triage</a:t>
+            </a:r>
+            <a:endParaRPr lang="en-US" sz="1500" dirty="0"/>
+          </a:p>
+        </p:txBody>
+      </p:sp>
+      <p:sp>
+        <p:nvSpPr>
           <p:cNvPr id="12" name="Text 10"/>
           <p:cNvSpPr txBox="1"/>
           <p:nvPr/>
         </p:nvSpPr>
         <p:spPr>
           <a:xfrm>
-            <a:off x="868680" y="4160520"/>
-            <a:ext cx="10424160" cy="457200"/>
+            <a:off x="1874520" y="3794760"/>
+            <a:ext cx="4434840" cy="320040"/>
           </a:xfrm>
           <a:prstGeom prst="rect">
             <a:avLst/>
@@ -4579,12 +4661,217 @@
               <a:buNone/>
             </a:pPr>
             <a:r>
+              <a:rPr lang="en-US" sz="1300" i="1" dirty="0">
+                <a:solidFill>
+                  <a:schemeClr val="accent3"/>
+                </a:solidFill>
+              </a:rPr>
+              <a:t>Medium: a service owner, central oversight</a:t>
+            </a:r>
+            <a:endParaRPr lang="en-US" sz="1300" dirty="0"/>
+          </a:p>
+        </p:txBody>
+      </p:sp>
+      <p:sp>
+        <p:nvSpPr>
+          <p:cNvPr id="13" name="Shape 11"/>
+          <p:cNvSpPr/>
+          <p:nvPr/>
+        </p:nvSpPr>
+        <p:spPr>
+          <a:xfrm>
+            <a:off x="1371600" y="4389120"/>
+            <a:ext cx="5212080" cy="1280160"/>
+          </a:xfrm>
+          <a:prstGeom prst="roundRect">
+            <a:avLst>
+              <a:gd name="adj" fmla="val 10714"/>
+            </a:avLst>
+          </a:prstGeom>
+          <a:solidFill>
+            <a:schemeClr val="tx2"/>
+          </a:solidFill>
+          <a:ln/>
+        </p:spPr>
+      </p:sp>
+      <p:sp>
+        <p:nvSpPr>
+          <p:cNvPr id="14" name="Text 12"/>
+          <p:cNvSpPr txBox="1"/>
+          <p:nvPr/>
+        </p:nvSpPr>
+        <p:spPr>
+          <a:xfrm>
+            <a:off x="1600200" y="4572000"/>
+            <a:ext cx="548640" cy="914400"/>
+          </a:xfrm>
+          <a:prstGeom prst="rect">
+            <a:avLst/>
+          </a:prstGeom>
+          <a:noFill/>
+          <a:ln/>
+        </p:spPr>
+        <p:txBody>
+          <a:bodyPr wrap="square" lIns="0" tIns="0" rIns="0" bIns="0" rtlCol="0" anchor="ctr"/>
+          <a:lstStyle/>
+          <a:p>
+            <a:pPr indent="0" marL="0">
+              <a:buNone/>
+            </a:pPr>
+            <a:r>
+              <a:rPr lang="en-US" sz="4000" b="1" dirty="0">
+                <a:solidFill>
+                  <a:schemeClr val="accent1"/>
+                </a:solidFill>
+                <a:latin typeface="Cambria" pitchFamily="34" charset="0"/>
+                <a:ea typeface="Cambria" pitchFamily="34" charset="-122"/>
+                <a:cs typeface="Cambria" pitchFamily="34" charset="-120"/>
+              </a:rPr>
+              <a:t>3</a:t>
+            </a:r>
+            <a:endParaRPr lang="en-US" sz="4000" dirty="0"/>
+          </a:p>
+        </p:txBody>
+      </p:sp>
+      <p:sp>
+        <p:nvSpPr>
+          <p:cNvPr id="15" name="Text 13"/>
+          <p:cNvSpPr txBox="1"/>
+          <p:nvPr/>
+        </p:nvSpPr>
+        <p:spPr>
+          <a:xfrm>
+            <a:off x="2286000" y="4526280"/>
+            <a:ext cx="3657600" cy="457200"/>
+          </a:xfrm>
+          <a:prstGeom prst="rect">
+            <a:avLst/>
+          </a:prstGeom>
+          <a:noFill/>
+          <a:ln/>
+        </p:spPr>
+        <p:txBody>
+          <a:bodyPr wrap="square" lIns="0" tIns="0" rIns="0" bIns="0" rtlCol="0" anchor="ctr"/>
+          <a:lstStyle/>
+          <a:p>
+            <a:pPr indent="0" marL="0">
+              <a:buNone/>
+            </a:pPr>
+            <a:r>
               <a:rPr lang="en-US" sz="2000" b="1" dirty="0">
                 <a:solidFill>
+                  <a:schemeClr val="bg1"/>
+                </a:solidFill>
+              </a:rPr>
+              <a:t>Organisation</a:t>
+            </a:r>
+            <a:endParaRPr lang="en-US" sz="2000" dirty="0"/>
+          </a:p>
+        </p:txBody>
+      </p:sp>
+      <p:sp>
+        <p:nvSpPr>
+          <p:cNvPr id="16" name="Text 14"/>
+          <p:cNvSpPr txBox="1"/>
+          <p:nvPr/>
+        </p:nvSpPr>
+        <p:spPr>
+          <a:xfrm>
+            <a:off x="2286000" y="4956048"/>
+            <a:ext cx="4023360" cy="320040"/>
+          </a:xfrm>
+          <a:prstGeom prst="rect">
+            <a:avLst/>
+          </a:prstGeom>
+          <a:noFill/>
+          <a:ln/>
+        </p:spPr>
+        <p:txBody>
+          <a:bodyPr wrap="square" lIns="0" tIns="0" rIns="0" bIns="0" rtlCol="0" anchor="ctr"/>
+          <a:lstStyle/>
+          <a:p>
+            <a:pPr indent="0" marL="0">
+              <a:buNone/>
+            </a:pPr>
+            <a:r>
+              <a:rPr lang="en-US" sz="1500" dirty="0">
+                <a:solidFill>
+                  <a:schemeClr val="bg2"/>
+                </a:solidFill>
+              </a:rPr>
+              <a:t>Public-facing tools, decision support</a:t>
+            </a:r>
+            <a:endParaRPr lang="en-US" sz="1500" dirty="0"/>
+          </a:p>
+        </p:txBody>
+      </p:sp>
+      <p:sp>
+        <p:nvSpPr>
+          <p:cNvPr id="17" name="Text 15"/>
+          <p:cNvSpPr txBox="1"/>
+          <p:nvPr/>
+        </p:nvSpPr>
+        <p:spPr>
+          <a:xfrm>
+            <a:off x="2286000" y="5257800"/>
+            <a:ext cx="4023360" cy="320040"/>
+          </a:xfrm>
+          <a:prstGeom prst="rect">
+            <a:avLst/>
+          </a:prstGeom>
+          <a:noFill/>
+          <a:ln/>
+        </p:spPr>
+        <p:txBody>
+          <a:bodyPr wrap="square" lIns="0" tIns="0" rIns="0" bIns="0" rtlCol="0" anchor="ctr"/>
+          <a:lstStyle/>
+          <a:p>
+            <a:pPr indent="0" marL="0">
+              <a:buNone/>
+            </a:pPr>
+            <a:r>
+              <a:rPr lang="en-US" sz="1300" i="1" dirty="0">
+                <a:solidFill>
+                  <a:schemeClr val="accent5"/>
+                </a:solidFill>
+              </a:rPr>
+              <a:t>High: formal approval and assurance</a:t>
+            </a:r>
+            <a:endParaRPr lang="en-US" sz="1300" dirty="0"/>
+          </a:p>
+        </p:txBody>
+      </p:sp>
+      <p:sp>
+        <p:nvSpPr>
+          <p:cNvPr id="18" name="Text 16"/>
+          <p:cNvSpPr txBox="1"/>
+          <p:nvPr/>
+        </p:nvSpPr>
+        <p:spPr>
+          <a:xfrm>
+            <a:off x="7223760" y="1463040"/>
+            <a:ext cx="4389120" cy="457200"/>
+          </a:xfrm>
+          <a:prstGeom prst="rect">
+            <a:avLst/>
+          </a:prstGeom>
+          <a:noFill/>
+          <a:ln/>
+        </p:spPr>
+        <p:txBody>
+          <a:bodyPr wrap="square" lIns="0" tIns="0" rIns="0" bIns="0" rtlCol="0" anchor="ctr"/>
+          <a:lstStyle/>
+          <a:p>
+            <a:pPr indent="0" marL="0">
+              <a:buNone/>
+            </a:pPr>
+            <a:r>
+              <a:rPr lang="en-US" sz="2000" b="1" dirty="0">
+                <a:solidFill>
                   <a:schemeClr val="tx2"/>
                 </a:solidFill>
               </a:rPr>
-              <a:t>What we are asking for</a:t>
+              <a:t>Manage AI like a new employee</a:t>
             </a:r>
             <a:endParaRPr lang="en-US" sz="2000" dirty="0"/>
           </a:p>
@@ -4592,14 +4879,478 @@
       </p:sp>
       <p:sp>
         <p:nvSpPr>
-          <p:cNvPr id="13" name="Text 11"/>
-          <p:cNvSpPr txBox="1"/>
-          <p:nvPr/>
-        </p:nvSpPr>
-        <p:spPr>
-          <a:xfrm>
-            <a:off x="868680" y="4617720"/>
-            <a:ext cx="10424160" cy="1463040"/>
+          <p:cNvPr id="19" name="Shape 17"/>
+          <p:cNvSpPr/>
+          <p:nvPr/>
+        </p:nvSpPr>
+        <p:spPr>
+          <a:xfrm>
+            <a:off x="7223760" y="2057400"/>
+            <a:ext cx="594360" cy="594360"/>
+          </a:xfrm>
+          <a:prstGeom prst="ellipse">
+            <a:avLst/>
+          </a:prstGeom>
+          <a:solidFill>
+            <a:schemeClr val="tx2"/>
+          </a:solidFill>
+          <a:ln/>
+        </p:spPr>
+      </p:sp>
+      <p:pic>
+        <p:nvPicPr>
+          <p:cNvPr id="20" name="Image 0" descr="preencoded.png">    </p:cNvPr>
+          <p:cNvPicPr>
+            <a:picLocks noChangeAspect="1"/>
+          </p:cNvPicPr>
+          <p:nvPr/>
+        </p:nvPicPr>
+        <p:blipFill>
+          <a:blip r:embed="rId1"/>
+          <a:stretch>
+            <a:fillRect/>
+          </a:stretch>
+        </p:blipFill>
+        <p:spPr>
+          <a:xfrm>
+            <a:off x="7370064" y="2203704"/>
+            <a:ext cx="301752" cy="301752"/>
+          </a:xfrm>
+          <a:prstGeom prst="rect">
+            <a:avLst/>
+          </a:prstGeom>
+        </p:spPr>
+      </p:pic>
+      <p:sp>
+        <p:nvSpPr>
+          <p:cNvPr id="21" name="Text 18"/>
+          <p:cNvSpPr txBox="1"/>
+          <p:nvPr/>
+        </p:nvSpPr>
+        <p:spPr>
+          <a:xfrm>
+            <a:off x="8001000" y="2011680"/>
+            <a:ext cx="3657600" cy="365760"/>
+          </a:xfrm>
+          <a:prstGeom prst="rect">
+            <a:avLst/>
+          </a:prstGeom>
+          <a:noFill/>
+          <a:ln/>
+        </p:spPr>
+        <p:txBody>
+          <a:bodyPr wrap="square" lIns="0" tIns="0" rIns="0" bIns="0" rtlCol="0" anchor="ctr"/>
+          <a:lstStyle/>
+          <a:p>
+            <a:pPr indent="0" marL="0">
+              <a:buNone/>
+            </a:pPr>
+            <a:r>
+              <a:rPr lang="en-US" sz="1600" b="1" dirty="0">
+                <a:solidFill>
+                  <a:schemeClr val="tx2"/>
+                </a:solidFill>
+              </a:rPr>
+              <a:t>A job description</a:t>
+            </a:r>
+            <a:endParaRPr lang="en-US" sz="1600" dirty="0"/>
+          </a:p>
+        </p:txBody>
+      </p:sp>
+      <p:sp>
+        <p:nvSpPr>
+          <p:cNvPr id="22" name="Text 19"/>
+          <p:cNvSpPr txBox="1"/>
+          <p:nvPr/>
+        </p:nvSpPr>
+        <p:spPr>
+          <a:xfrm>
+            <a:off x="8001000" y="2350008"/>
+            <a:ext cx="3657600" cy="320040"/>
+          </a:xfrm>
+          <a:prstGeom prst="rect">
+            <a:avLst/>
+          </a:prstGeom>
+          <a:noFill/>
+          <a:ln/>
+        </p:spPr>
+        <p:txBody>
+          <a:bodyPr wrap="square" lIns="0" tIns="0" rIns="0" bIns="0" rtlCol="0" anchor="ctr"/>
+          <a:lstStyle/>
+          <a:p>
+            <a:pPr indent="0" marL="0">
+              <a:buNone/>
+            </a:pPr>
+            <a:r>
+              <a:rPr lang="en-US" sz="1400" dirty="0">
+                <a:solidFill>
+                  <a:schemeClr val="tx1"/>
+                </a:solidFill>
+              </a:rPr>
+              <a:t>a clear task, data and limits</a:t>
+            </a:r>
+            <a:endParaRPr lang="en-US" sz="1400" dirty="0"/>
+          </a:p>
+        </p:txBody>
+      </p:sp>
+      <p:sp>
+        <p:nvSpPr>
+          <p:cNvPr id="23" name="Shape 20"/>
+          <p:cNvSpPr/>
+          <p:nvPr/>
+        </p:nvSpPr>
+        <p:spPr>
+          <a:xfrm>
+            <a:off x="7223760" y="2926080"/>
+            <a:ext cx="594360" cy="594360"/>
+          </a:xfrm>
+          <a:prstGeom prst="ellipse">
+            <a:avLst/>
+          </a:prstGeom>
+          <a:solidFill>
+            <a:schemeClr val="tx2"/>
+          </a:solidFill>
+          <a:ln/>
+        </p:spPr>
+      </p:sp>
+      <p:pic>
+        <p:nvPicPr>
+          <p:cNvPr id="24" name="Image 1" descr="preencoded.png">    </p:cNvPr>
+          <p:cNvPicPr>
+            <a:picLocks noChangeAspect="1"/>
+          </p:cNvPicPr>
+          <p:nvPr/>
+        </p:nvPicPr>
+        <p:blipFill>
+          <a:blip r:embed="rId2"/>
+          <a:stretch>
+            <a:fillRect/>
+          </a:stretch>
+        </p:blipFill>
+        <p:spPr>
+          <a:xfrm>
+            <a:off x="7370064" y="3072384"/>
+            <a:ext cx="301752" cy="301752"/>
+          </a:xfrm>
+          <a:prstGeom prst="rect">
+            <a:avLst/>
+          </a:prstGeom>
+        </p:spPr>
+      </p:pic>
+      <p:sp>
+        <p:nvSpPr>
+          <p:cNvPr id="25" name="Text 21"/>
+          <p:cNvSpPr txBox="1"/>
+          <p:nvPr/>
+        </p:nvSpPr>
+        <p:spPr>
+          <a:xfrm>
+            <a:off x="8001000" y="2880360"/>
+            <a:ext cx="3657600" cy="365760"/>
+          </a:xfrm>
+          <a:prstGeom prst="rect">
+            <a:avLst/>
+          </a:prstGeom>
+          <a:noFill/>
+          <a:ln/>
+        </p:spPr>
+        <p:txBody>
+          <a:bodyPr wrap="square" lIns="0" tIns="0" rIns="0" bIns="0" rtlCol="0" anchor="ctr"/>
+          <a:lstStyle/>
+          <a:p>
+            <a:pPr indent="0" marL="0">
+              <a:buNone/>
+            </a:pPr>
+            <a:r>
+              <a:rPr lang="en-US" sz="1600" b="1" dirty="0">
+                <a:solidFill>
+                  <a:schemeClr val="tx2"/>
+                </a:solidFill>
+              </a:rPr>
+              <a:t>A trial period</a:t>
+            </a:r>
+            <a:endParaRPr lang="en-US" sz="1600" dirty="0"/>
+          </a:p>
+        </p:txBody>
+      </p:sp>
+      <p:sp>
+        <p:nvSpPr>
+          <p:cNvPr id="26" name="Text 22"/>
+          <p:cNvSpPr txBox="1"/>
+          <p:nvPr/>
+        </p:nvSpPr>
+        <p:spPr>
+          <a:xfrm>
+            <a:off x="8001000" y="3218688"/>
+            <a:ext cx="3657600" cy="320040"/>
+          </a:xfrm>
+          <a:prstGeom prst="rect">
+            <a:avLst/>
+          </a:prstGeom>
+          <a:noFill/>
+          <a:ln/>
+        </p:spPr>
+        <p:txBody>
+          <a:bodyPr wrap="square" lIns="0" tIns="0" rIns="0" bIns="0" rtlCol="0" anchor="ctr"/>
+          <a:lstStyle/>
+          <a:p>
+            <a:pPr indent="0" marL="0">
+              <a:buNone/>
+            </a:pPr>
+            <a:r>
+              <a:rPr lang="en-US" sz="1400" dirty="0">
+                <a:solidFill>
+                  <a:schemeClr val="tx1"/>
+                </a:solidFill>
+              </a:rPr>
+              <a:t>a limited roll-out first</a:t>
+            </a:r>
+            <a:endParaRPr lang="en-US" sz="1400" dirty="0"/>
+          </a:p>
+        </p:txBody>
+      </p:sp>
+      <p:sp>
+        <p:nvSpPr>
+          <p:cNvPr id="27" name="Shape 23"/>
+          <p:cNvSpPr/>
+          <p:nvPr/>
+        </p:nvSpPr>
+        <p:spPr>
+          <a:xfrm>
+            <a:off x="7223760" y="3794760"/>
+            <a:ext cx="594360" cy="594360"/>
+          </a:xfrm>
+          <a:prstGeom prst="ellipse">
+            <a:avLst/>
+          </a:prstGeom>
+          <a:solidFill>
+            <a:schemeClr val="tx2"/>
+          </a:solidFill>
+          <a:ln/>
+        </p:spPr>
+      </p:sp>
+      <p:pic>
+        <p:nvPicPr>
+          <p:cNvPr id="28" name="Image 2" descr="preencoded.png">    </p:cNvPr>
+          <p:cNvPicPr>
+            <a:picLocks noChangeAspect="1"/>
+          </p:cNvPicPr>
+          <p:nvPr/>
+        </p:nvPicPr>
+        <p:blipFill>
+          <a:blip r:embed="rId3"/>
+          <a:stretch>
+            <a:fillRect/>
+          </a:stretch>
+        </p:blipFill>
+        <p:spPr>
+          <a:xfrm>
+            <a:off x="7370064" y="3941064"/>
+            <a:ext cx="301752" cy="301752"/>
+          </a:xfrm>
+          <a:prstGeom prst="rect">
+            <a:avLst/>
+          </a:prstGeom>
+        </p:spPr>
+      </p:pic>
+      <p:sp>
+        <p:nvSpPr>
+          <p:cNvPr id="29" name="Text 24"/>
+          <p:cNvSpPr txBox="1"/>
+          <p:nvPr/>
+        </p:nvSpPr>
+        <p:spPr>
+          <a:xfrm>
+            <a:off x="8001000" y="3749040"/>
+            <a:ext cx="3657600" cy="365760"/>
+          </a:xfrm>
+          <a:prstGeom prst="rect">
+            <a:avLst/>
+          </a:prstGeom>
+          <a:noFill/>
+          <a:ln/>
+        </p:spPr>
+        <p:txBody>
+          <a:bodyPr wrap="square" lIns="0" tIns="0" rIns="0" bIns="0" rtlCol="0" anchor="ctr"/>
+          <a:lstStyle/>
+          <a:p>
+            <a:pPr indent="0" marL="0">
+              <a:buNone/>
+            </a:pPr>
+            <a:r>
+              <a:rPr lang="en-US" sz="1600" b="1" dirty="0">
+                <a:solidFill>
+                  <a:schemeClr val="tx2"/>
+                </a:solidFill>
+              </a:rPr>
+              <a:t>Performance reviews</a:t>
+            </a:r>
+            <a:endParaRPr lang="en-US" sz="1600" dirty="0"/>
+          </a:p>
+        </p:txBody>
+      </p:sp>
+      <p:sp>
+        <p:nvSpPr>
+          <p:cNvPr id="30" name="Text 25"/>
+          <p:cNvSpPr txBox="1"/>
+          <p:nvPr/>
+        </p:nvSpPr>
+        <p:spPr>
+          <a:xfrm>
+            <a:off x="8001000" y="4087368"/>
+            <a:ext cx="3657600" cy="320040"/>
+          </a:xfrm>
+          <a:prstGeom prst="rect">
+            <a:avLst/>
+          </a:prstGeom>
+          <a:noFill/>
+          <a:ln/>
+        </p:spPr>
+        <p:txBody>
+          <a:bodyPr wrap="square" lIns="0" tIns="0" rIns="0" bIns="0" rtlCol="0" anchor="ctr"/>
+          <a:lstStyle/>
+          <a:p>
+            <a:pPr indent="0" marL="0">
+              <a:buNone/>
+            </a:pPr>
+            <a:r>
+              <a:rPr lang="en-US" sz="1400" dirty="0">
+                <a:solidFill>
+                  <a:schemeClr val="tx1"/>
+                </a:solidFill>
+              </a:rPr>
+              <a:t>measured and monitored</a:t>
+            </a:r>
+            <a:endParaRPr lang="en-US" sz="1400" dirty="0"/>
+          </a:p>
+        </p:txBody>
+      </p:sp>
+      <p:sp>
+        <p:nvSpPr>
+          <p:cNvPr id="31" name="Shape 26"/>
+          <p:cNvSpPr/>
+          <p:nvPr/>
+        </p:nvSpPr>
+        <p:spPr>
+          <a:xfrm>
+            <a:off x="7223760" y="4663440"/>
+            <a:ext cx="594360" cy="594360"/>
+          </a:xfrm>
+          <a:prstGeom prst="ellipse">
+            <a:avLst/>
+          </a:prstGeom>
+          <a:solidFill>
+            <a:schemeClr val="tx2"/>
+          </a:solidFill>
+          <a:ln/>
+        </p:spPr>
+      </p:sp>
+      <p:pic>
+        <p:nvPicPr>
+          <p:cNvPr id="32" name="Image 3" descr="preencoded.png">    </p:cNvPr>
+          <p:cNvPicPr>
+            <a:picLocks noChangeAspect="1"/>
+          </p:cNvPicPr>
+          <p:nvPr/>
+        </p:nvPicPr>
+        <p:blipFill>
+          <a:blip r:embed="rId4"/>
+          <a:stretch>
+            <a:fillRect/>
+          </a:stretch>
+        </p:blipFill>
+        <p:spPr>
+          <a:xfrm>
+            <a:off x="7370064" y="4809744"/>
+            <a:ext cx="301752" cy="301752"/>
+          </a:xfrm>
+          <a:prstGeom prst="rect">
+            <a:avLst/>
+          </a:prstGeom>
+        </p:spPr>
+      </p:pic>
+      <p:sp>
+        <p:nvSpPr>
+          <p:cNvPr id="33" name="Text 27"/>
+          <p:cNvSpPr txBox="1"/>
+          <p:nvPr/>
+        </p:nvSpPr>
+        <p:spPr>
+          <a:xfrm>
+            <a:off x="8001000" y="4617720"/>
+            <a:ext cx="3657600" cy="365760"/>
+          </a:xfrm>
+          <a:prstGeom prst="rect">
+            <a:avLst/>
+          </a:prstGeom>
+          <a:noFill/>
+          <a:ln/>
+        </p:spPr>
+        <p:txBody>
+          <a:bodyPr wrap="square" lIns="0" tIns="0" rIns="0" bIns="0" rtlCol="0" anchor="ctr"/>
+          <a:lstStyle/>
+          <a:p>
+            <a:pPr indent="0" marL="0">
+              <a:buNone/>
+            </a:pPr>
+            <a:r>
+              <a:rPr lang="en-US" sz="1600" b="1" dirty="0">
+                <a:solidFill>
+                  <a:schemeClr val="tx2"/>
+                </a:solidFill>
+              </a:rPr>
+              <a:t>Can be switched off</a:t>
+            </a:r>
+            <a:endParaRPr lang="en-US" sz="1600" dirty="0"/>
+          </a:p>
+        </p:txBody>
+      </p:sp>
+      <p:sp>
+        <p:nvSpPr>
+          <p:cNvPr id="34" name="Text 28"/>
+          <p:cNvSpPr txBox="1"/>
+          <p:nvPr/>
+        </p:nvSpPr>
+        <p:spPr>
+          <a:xfrm>
+            <a:off x="8001000" y="4956048"/>
+            <a:ext cx="3657600" cy="320040"/>
+          </a:xfrm>
+          <a:prstGeom prst="rect">
+            <a:avLst/>
+          </a:prstGeom>
+          <a:noFill/>
+          <a:ln/>
+        </p:spPr>
+        <p:txBody>
+          <a:bodyPr wrap="square" lIns="0" tIns="0" rIns="0" bIns="0" rtlCol="0" anchor="ctr"/>
+          <a:lstStyle/>
+          <a:p>
+            <a:pPr indent="0" marL="0">
+              <a:buNone/>
+            </a:pPr>
+            <a:r>
+              <a:rPr lang="en-US" sz="1400" dirty="0">
+                <a:solidFill>
+                  <a:schemeClr val="tx1"/>
+                </a:solidFill>
+              </a:rPr>
+              <a:t>a person stays accountable</a:t>
+            </a:r>
+            <a:endParaRPr lang="en-US" sz="1400" dirty="0"/>
+          </a:p>
+        </p:txBody>
+      </p:sp>
+      <p:sp>
+        <p:nvSpPr>
+          <p:cNvPr id="35" name="Text 29"/>
+          <p:cNvSpPr txBox="1"/>
+          <p:nvPr/>
+        </p:nvSpPr>
+        <p:spPr>
+          <a:xfrm>
+            <a:off x="7223760" y="5577840"/>
+            <a:ext cx="4389120" cy="685800"/>
           </a:xfrm>
           <a:prstGeom prst="rect">
             <a:avLst/>
@@ -4611,71 +5362,31 @@
           <a:bodyPr wrap="square" lIns="0" tIns="0" rIns="0" bIns="0" rtlCol="0" anchor="t"/>
           <a:lstStyle/>
           <a:p>
-            <a:pPr marL="342900" indent="-342900">
-              <a:spcAft>
-                <a:spcPts val="600"/>
-              </a:spcAft>
-              <a:buSzPct val="100000"/>
-              <a:buChar char="•"/>
-            </a:pPr>
-            <a:r>
-              <a:rPr lang="en-US" sz="1700" dirty="0">
-                <a:solidFill>
-                  <a:schemeClr val="tx1"/>
-                </a:solidFill>
-              </a:rPr>
-              <a:t>Stand up an AI build team and a cloud strategy, with an executive sponsor</a:t>
-            </a:r>
-            <a:endParaRPr lang="en-US" sz="1700" dirty="0"/>
-          </a:p>
-          <a:p>
-            <a:pPr marL="342900" indent="-342900">
-              <a:spcAft>
-                <a:spcPts val="600"/>
-              </a:spcAft>
-              <a:buSzPct val="100000"/>
-              <a:buChar char="•"/>
-            </a:pPr>
-            <a:r>
-              <a:rPr lang="en-US" sz="1700" dirty="0">
-                <a:solidFill>
-                  <a:schemeClr val="tx1"/>
-                </a:solidFill>
-              </a:rPr>
-              <a:t>Change our filing rules and portal through the Rules of Practice review already under way</a:t>
-            </a:r>
-            <a:endParaRPr lang="en-US" sz="1700" dirty="0"/>
-          </a:p>
-          <a:p>
-            <a:pPr marL="342900" indent="-342900">
-              <a:spcAft>
-                <a:spcPts val="600"/>
-              </a:spcAft>
-              <a:buSzPct val="100000"/>
-              <a:buChar char="•"/>
-            </a:pPr>
-            <a:r>
-              <a:rPr lang="en-US" sz="1700" dirty="0">
-                <a:solidFill>
-                  <a:schemeClr val="tx1"/>
-                </a:solidFill>
-              </a:rPr>
-              <a:t>Start now with two quick wins: the automatic upload check, and a privacy review of flawed redactions</a:t>
-            </a:r>
-            <a:endParaRPr lang="en-US" sz="1700" dirty="0"/>
-          </a:p>
-        </p:txBody>
-      </p:sp>
-      <p:sp>
-        <p:nvSpPr>
-          <p:cNvPr id="14" name="Text 12"/>
-          <p:cNvSpPr txBox="1"/>
-          <p:nvPr/>
-        </p:nvSpPr>
-        <p:spPr>
-          <a:xfrm>
-            <a:off x="548640" y="6263640"/>
-            <a:ext cx="10424160" cy="365760"/>
+            <a:pPr indent="0" marL="0">
+              <a:buNone/>
+            </a:pPr>
+            <a:r>
+              <a:rPr lang="en-US" sz="1300" i="1" dirty="0">
+                <a:solidFill>
+                  <a:schemeClr val="accent3"/>
+                </a:solidFill>
+              </a:rPr>
+              <a:t>Train every level: all staff to use AI safely, team leads to build it into their work, executives to weigh risk and value.</a:t>
+            </a:r>
+            <a:endParaRPr lang="en-US" sz="1300" dirty="0"/>
+          </a:p>
+        </p:txBody>
+      </p:sp>
+      <p:sp>
+        <p:nvSpPr>
+          <p:cNvPr id="36" name="Text 30"/>
+          <p:cNvSpPr txBox="1"/>
+          <p:nvPr/>
+        </p:nvSpPr>
+        <p:spPr>
+          <a:xfrm>
+            <a:off x="548640" y="5989320"/>
+            <a:ext cx="6400800" cy="320040"/>
           </a:xfrm>
           <a:prstGeom prst="rect">
             <a:avLst/>
@@ -4691,14 +5402,14 @@
               <a:buNone/>
             </a:pPr>
             <a:r>
-              <a:rPr lang="en-US" sz="1200" i="1" dirty="0">
-                <a:solidFill>
-                  <a:schemeClr val="bg2"/>
-                </a:solidFill>
-              </a:rPr>
-              <a:t>“Agentic AI is not primarily a technology challenge.”  — UK Local Government Association, 2026</a:t>
-            </a:r>
-            <a:endParaRPr lang="en-US" sz="1200" dirty="0"/>
+              <a:rPr lang="en-US" sz="1100" dirty="0">
+                <a:solidFill>
+                  <a:schemeClr val="accent3"/>
+                </a:solidFill>
+              </a:rPr>
+              <a:t>Adapted from the UK Local Government Association’s playbook for agentic AI (2026).</a:t>
+            </a:r>
+            <a:endParaRPr lang="en-US" sz="1100" dirty="0"/>
           </a:p>
         </p:txBody>
       </p:sp>
@@ -4732,7 +5443,7 @@
             <a:lvl1pPr>
               <a:defRPr sz="1000">
                 <a:solidFill>
-                  <a:schemeClr val="bg2"/>
+                  <a:schemeClr val="accent3"/>
                 </a:solidFill>
               </a:defRPr>
             </a:lvl1pPr>
@@ -4742,6 +5453,572 @@
             <a:fld id="{F7021451-1387-4CA6-816F-3879F97B5CBC}" type="slidenum">
               <a:rPr b="0" lang="en-US"/>
               <a:t>12</a:t>
+            </a:fld>
+            <a:endParaRPr lang="en-US"/>
+          </a:p>
+        </p:txBody>
+      </p:sp>
+    </p:spTree>
+  </p:cSld>
+  <p:clrMapOvr>
+    <a:masterClrMapping/>
+  </p:clrMapOvr>
+</p:sld>
+</file>
+
+<file path=ppt/slides/slide13.xml><?xml version="1.0" encoding="utf-8"?>
+<p:sld xmlns:a="http://schemas.openxmlformats.org/drawingml/2006/main" xmlns:r="http://schemas.openxmlformats.org/officeDocument/2006/relationships" xmlns:p="http://schemas.openxmlformats.org/presentationml/2006/main">
+  <p:cSld name="Slide 13">
+    <p:spTree>
+      <p:nvGrpSpPr>
+        <p:cNvPr id="1" name=""/>
+        <p:cNvGrpSpPr/>
+        <p:nvPr/>
+      </p:nvGrpSpPr>
+      <p:grpSpPr>
+        <a:xfrm>
+          <a:off x="0" y="0"/>
+          <a:ext cx="0" cy="0"/>
+          <a:chOff x="0" y="0"/>
+          <a:chExt cx="0" cy="0"/>
+        </a:xfrm>
+      </p:grpSpPr>
+      <p:sp>
+        <p:nvSpPr>
+          <p:cNvPr id="2" name="Text 0"/>
+          <p:cNvSpPr/>
+          <p:nvPr>
+            <p:ph idx="100" type="title" hasCustomPrompt="1"/>
+          </p:nvPr>
+        </p:nvSpPr>
+        <p:spPr>
+          <a:xfrm>
+            <a:off x="548640" y="365760"/>
+            <a:ext cx="11064240" cy="822960"/>
+          </a:xfrm>
+          <a:prstGeom prst="rect">
+            <a:avLst/>
+          </a:prstGeom>
+          <a:noFill/>
+          <a:ln/>
+        </p:spPr>
+        <p:txBody>
+          <a:bodyPr wrap="square" lIns="0" tIns="0" rIns="0" bIns="0" rtlCol="0" anchor="ctr"/>
+          <a:lstStyle/>
+          <a:p>
+            <a:pPr indent="0" marL="0">
+              <a:buNone/>
+            </a:pPr>
+            <a:r>
+              <a:rPr lang="en-US" sz="3400" b="1" dirty="0">
+                <a:solidFill>
+                  <a:schemeClr val="bg1"/>
+                </a:solidFill>
+              </a:rPr>
+              <a:t>Lessons for every part of the organization</a:t>
+            </a:r>
+            <a:endParaRPr lang="en-US" sz="3400" dirty="0"/>
+          </a:p>
+        </p:txBody>
+      </p:sp>
+      <p:sp>
+        <p:nvSpPr>
+          <p:cNvPr id="3" name="Text 1"/>
+          <p:cNvSpPr txBox="1"/>
+          <p:nvPr/>
+        </p:nvSpPr>
+        <p:spPr>
+          <a:xfrm>
+            <a:off x="548640" y="1417320"/>
+            <a:ext cx="5394960" cy="502920"/>
+          </a:xfrm>
+          <a:prstGeom prst="rect">
+            <a:avLst/>
+          </a:prstGeom>
+          <a:noFill/>
+          <a:ln/>
+        </p:spPr>
+        <p:txBody>
+          <a:bodyPr wrap="square" lIns="0" tIns="0" rIns="0" bIns="0" rtlCol="0" anchor="ctr"/>
+          <a:lstStyle/>
+          <a:p>
+            <a:pPr indent="0" marL="0">
+              <a:buNone/>
+            </a:pPr>
+            <a:r>
+              <a:rPr lang="en-US" sz="2100" b="1" dirty="0">
+                <a:solidFill>
+                  <a:schemeClr val="accent1"/>
+                </a:solidFill>
+              </a:rPr>
+              <a:t>AI is only as good as its data</a:t>
+            </a:r>
+            <a:endParaRPr lang="en-US" sz="2100" dirty="0"/>
+          </a:p>
+        </p:txBody>
+      </p:sp>
+      <p:sp>
+        <p:nvSpPr>
+          <p:cNvPr id="4" name="Text 2"/>
+          <p:cNvSpPr txBox="1"/>
+          <p:nvPr/>
+        </p:nvSpPr>
+        <p:spPr>
+          <a:xfrm>
+            <a:off x="548640" y="1920240"/>
+            <a:ext cx="5394960" cy="548640"/>
+          </a:xfrm>
+          <a:prstGeom prst="rect">
+            <a:avLst/>
+          </a:prstGeom>
+          <a:noFill/>
+          <a:ln/>
+        </p:spPr>
+        <p:txBody>
+          <a:bodyPr wrap="square" lIns="0" tIns="0" rIns="0" bIns="0" rtlCol="0" anchor="t"/>
+          <a:lstStyle/>
+          <a:p>
+            <a:pPr indent="0" marL="0">
+              <a:buNone/>
+            </a:pPr>
+            <a:r>
+              <a:rPr lang="en-US" sz="1600" dirty="0">
+                <a:solidFill>
+                  <a:schemeClr val="bg2"/>
+                </a:solidFill>
+              </a:rPr>
+              <a:t>Fix data where it is created, not after.</a:t>
+            </a:r>
+            <a:endParaRPr lang="en-US" sz="1600" dirty="0"/>
+          </a:p>
+        </p:txBody>
+      </p:sp>
+      <p:sp>
+        <p:nvSpPr>
+          <p:cNvPr id="5" name="Text 3"/>
+          <p:cNvSpPr txBox="1"/>
+          <p:nvPr/>
+        </p:nvSpPr>
+        <p:spPr>
+          <a:xfrm>
+            <a:off x="6217920" y="1417320"/>
+            <a:ext cx="5394960" cy="502920"/>
+          </a:xfrm>
+          <a:prstGeom prst="rect">
+            <a:avLst/>
+          </a:prstGeom>
+          <a:noFill/>
+          <a:ln/>
+        </p:spPr>
+        <p:txBody>
+          <a:bodyPr wrap="square" lIns="0" tIns="0" rIns="0" bIns="0" rtlCol="0" anchor="ctr"/>
+          <a:lstStyle/>
+          <a:p>
+            <a:pPr indent="0" marL="0">
+              <a:buNone/>
+            </a:pPr>
+            <a:r>
+              <a:rPr lang="en-US" sz="2100" b="1" dirty="0">
+                <a:solidFill>
+                  <a:schemeClr val="accent1"/>
+                </a:solidFill>
+              </a:rPr>
+              <a:t>Failures are silent</a:t>
+            </a:r>
+            <a:endParaRPr lang="en-US" sz="2100" dirty="0"/>
+          </a:p>
+        </p:txBody>
+      </p:sp>
+      <p:sp>
+        <p:nvSpPr>
+          <p:cNvPr id="6" name="Text 4"/>
+          <p:cNvSpPr txBox="1"/>
+          <p:nvPr/>
+        </p:nvSpPr>
+        <p:spPr>
+          <a:xfrm>
+            <a:off x="6217920" y="1920240"/>
+            <a:ext cx="5394960" cy="548640"/>
+          </a:xfrm>
+          <a:prstGeom prst="rect">
+            <a:avLst/>
+          </a:prstGeom>
+          <a:noFill/>
+          <a:ln/>
+        </p:spPr>
+        <p:txBody>
+          <a:bodyPr wrap="square" lIns="0" tIns="0" rIns="0" bIns="0" rtlCol="0" anchor="t"/>
+          <a:lstStyle/>
+          <a:p>
+            <a:pPr indent="0" marL="0">
+              <a:buNone/>
+            </a:pPr>
+            <a:r>
+              <a:rPr lang="en-US" sz="1600" dirty="0">
+                <a:solidFill>
+                  <a:schemeClr val="bg2"/>
+                </a:solidFill>
+              </a:rPr>
+              <a:t>A system can look finished and be wrong. Ask for proof.</a:t>
+            </a:r>
+            <a:endParaRPr lang="en-US" sz="1600" dirty="0"/>
+          </a:p>
+        </p:txBody>
+      </p:sp>
+      <p:sp>
+        <p:nvSpPr>
+          <p:cNvPr id="7" name="Text 5"/>
+          <p:cNvSpPr txBox="1"/>
+          <p:nvPr/>
+        </p:nvSpPr>
+        <p:spPr>
+          <a:xfrm>
+            <a:off x="548640" y="2651760"/>
+            <a:ext cx="5394960" cy="502920"/>
+          </a:xfrm>
+          <a:prstGeom prst="rect">
+            <a:avLst/>
+          </a:prstGeom>
+          <a:noFill/>
+          <a:ln/>
+        </p:spPr>
+        <p:txBody>
+          <a:bodyPr wrap="square" lIns="0" tIns="0" rIns="0" bIns="0" rtlCol="0" anchor="ctr"/>
+          <a:lstStyle/>
+          <a:p>
+            <a:pPr indent="0" marL="0">
+              <a:buNone/>
+            </a:pPr>
+            <a:r>
+              <a:rPr lang="en-US" sz="2100" b="1" dirty="0">
+                <a:solidFill>
+                  <a:schemeClr val="accent1"/>
+                </a:solidFill>
+              </a:rPr>
+              <a:t>Rules beat advice</a:t>
+            </a:r>
+            <a:endParaRPr lang="en-US" sz="2100" dirty="0"/>
+          </a:p>
+        </p:txBody>
+      </p:sp>
+      <p:sp>
+        <p:nvSpPr>
+          <p:cNvPr id="8" name="Text 6"/>
+          <p:cNvSpPr txBox="1"/>
+          <p:nvPr/>
+        </p:nvSpPr>
+        <p:spPr>
+          <a:xfrm>
+            <a:off x="548640" y="3154680"/>
+            <a:ext cx="5394960" cy="548640"/>
+          </a:xfrm>
+          <a:prstGeom prst="rect">
+            <a:avLst/>
+          </a:prstGeom>
+          <a:noFill/>
+          <a:ln/>
+        </p:spPr>
+        <p:txBody>
+          <a:bodyPr wrap="square" lIns="0" tIns="0" rIns="0" bIns="0" rtlCol="0" anchor="t"/>
+          <a:lstStyle/>
+          <a:p>
+            <a:pPr indent="0" marL="0">
+              <a:buNone/>
+            </a:pPr>
+            <a:r>
+              <a:rPr lang="en-US" sz="1600" dirty="0">
+                <a:solidFill>
+                  <a:schemeClr val="bg2"/>
+                </a:solidFill>
+              </a:rPr>
+              <a:t>Build checks into systems instead of writing guidance.</a:t>
+            </a:r>
+            <a:endParaRPr lang="en-US" sz="1600" dirty="0"/>
+          </a:p>
+        </p:txBody>
+      </p:sp>
+      <p:sp>
+        <p:nvSpPr>
+          <p:cNvPr id="9" name="Text 7"/>
+          <p:cNvSpPr txBox="1"/>
+          <p:nvPr/>
+        </p:nvSpPr>
+        <p:spPr>
+          <a:xfrm>
+            <a:off x="6217920" y="2651760"/>
+            <a:ext cx="5394960" cy="502920"/>
+          </a:xfrm>
+          <a:prstGeom prst="rect">
+            <a:avLst/>
+          </a:prstGeom>
+          <a:noFill/>
+          <a:ln/>
+        </p:spPr>
+        <p:txBody>
+          <a:bodyPr wrap="square" lIns="0" tIns="0" rIns="0" bIns="0" rtlCol="0" anchor="ctr"/>
+          <a:lstStyle/>
+          <a:p>
+            <a:pPr indent="0" marL="0">
+              <a:buNone/>
+            </a:pPr>
+            <a:r>
+              <a:rPr lang="en-US" sz="2100" b="1" dirty="0">
+                <a:solidFill>
+                  <a:schemeClr val="accent1"/>
+                </a:solidFill>
+              </a:rPr>
+              <a:t>Small habits add up</a:t>
+            </a:r>
+            <a:endParaRPr lang="en-US" sz="2100" dirty="0"/>
+          </a:p>
+        </p:txBody>
+      </p:sp>
+      <p:sp>
+        <p:nvSpPr>
+          <p:cNvPr id="10" name="Text 8"/>
+          <p:cNvSpPr txBox="1"/>
+          <p:nvPr/>
+        </p:nvSpPr>
+        <p:spPr>
+          <a:xfrm>
+            <a:off x="6217920" y="3154680"/>
+            <a:ext cx="5394960" cy="548640"/>
+          </a:xfrm>
+          <a:prstGeom prst="rect">
+            <a:avLst/>
+          </a:prstGeom>
+          <a:noFill/>
+          <a:ln/>
+        </p:spPr>
+        <p:txBody>
+          <a:bodyPr wrap="square" lIns="0" tIns="0" rIns="0" bIns="0" rtlCol="0" anchor="t"/>
+          <a:lstStyle/>
+          <a:p>
+            <a:pPr indent="0" marL="0">
+              <a:buNone/>
+            </a:pPr>
+            <a:r>
+              <a:rPr lang="en-US" sz="1600" dirty="0">
+                <a:solidFill>
+                  <a:schemeClr val="bg2"/>
+                </a:solidFill>
+              </a:rPr>
+              <a:t>Printing to sign made nearly half the problem.</a:t>
+            </a:r>
+            <a:endParaRPr lang="en-US" sz="1600" dirty="0"/>
+          </a:p>
+        </p:txBody>
+      </p:sp>
+      <p:sp>
+        <p:nvSpPr>
+          <p:cNvPr id="11" name="Shape 9"/>
+          <p:cNvSpPr/>
+          <p:nvPr/>
+        </p:nvSpPr>
+        <p:spPr>
+          <a:xfrm>
+            <a:off x="548640" y="3977640"/>
+            <a:ext cx="11064240" cy="2194560"/>
+          </a:xfrm>
+          <a:prstGeom prst="roundRect">
+            <a:avLst>
+              <a:gd name="adj" fmla="val 6250"/>
+            </a:avLst>
+          </a:prstGeom>
+          <a:solidFill>
+            <a:schemeClr val="bg1"/>
+          </a:solidFill>
+          <a:ln/>
+        </p:spPr>
+      </p:sp>
+      <p:sp>
+        <p:nvSpPr>
+          <p:cNvPr id="12" name="Text 10"/>
+          <p:cNvSpPr txBox="1"/>
+          <p:nvPr/>
+        </p:nvSpPr>
+        <p:spPr>
+          <a:xfrm>
+            <a:off x="868680" y="4160520"/>
+            <a:ext cx="10424160" cy="457200"/>
+          </a:xfrm>
+          <a:prstGeom prst="rect">
+            <a:avLst/>
+          </a:prstGeom>
+          <a:noFill/>
+          <a:ln/>
+        </p:spPr>
+        <p:txBody>
+          <a:bodyPr wrap="square" lIns="0" tIns="0" rIns="0" bIns="0" rtlCol="0" anchor="ctr"/>
+          <a:lstStyle/>
+          <a:p>
+            <a:pPr indent="0" marL="0">
+              <a:buNone/>
+            </a:pPr>
+            <a:r>
+              <a:rPr lang="en-US" sz="2000" b="1" dirty="0">
+                <a:solidFill>
+                  <a:schemeClr val="tx2"/>
+                </a:solidFill>
+              </a:rPr>
+              <a:t>What we are asking for</a:t>
+            </a:r>
+            <a:endParaRPr lang="en-US" sz="2000" dirty="0"/>
+          </a:p>
+        </p:txBody>
+      </p:sp>
+      <p:sp>
+        <p:nvSpPr>
+          <p:cNvPr id="13" name="Text 11"/>
+          <p:cNvSpPr txBox="1"/>
+          <p:nvPr/>
+        </p:nvSpPr>
+        <p:spPr>
+          <a:xfrm>
+            <a:off x="868680" y="4617720"/>
+            <a:ext cx="10424160" cy="1463040"/>
+          </a:xfrm>
+          <a:prstGeom prst="rect">
+            <a:avLst/>
+          </a:prstGeom>
+          <a:noFill/>
+          <a:ln/>
+        </p:spPr>
+        <p:txBody>
+          <a:bodyPr wrap="square" lIns="0" tIns="0" rIns="0" bIns="0" rtlCol="0" anchor="t"/>
+          <a:lstStyle/>
+          <a:p>
+            <a:pPr marL="342900" indent="-342900">
+              <a:spcAft>
+                <a:spcPts val="600"/>
+              </a:spcAft>
+              <a:buSzPct val="100000"/>
+              <a:buChar char="•"/>
+            </a:pPr>
+            <a:r>
+              <a:rPr lang="en-US" sz="1700" dirty="0">
+                <a:solidFill>
+                  <a:schemeClr val="tx1"/>
+                </a:solidFill>
+              </a:rPr>
+              <a:t>Stand up an AI build team and a cloud strategy, with an executive sponsor</a:t>
+            </a:r>
+            <a:endParaRPr lang="en-US" sz="1700" dirty="0"/>
+          </a:p>
+          <a:p>
+            <a:pPr marL="342900" indent="-342900">
+              <a:spcAft>
+                <a:spcPts val="600"/>
+              </a:spcAft>
+              <a:buSzPct val="100000"/>
+              <a:buChar char="•"/>
+            </a:pPr>
+            <a:r>
+              <a:rPr lang="en-US" sz="1700" dirty="0">
+                <a:solidFill>
+                  <a:schemeClr val="tx1"/>
+                </a:solidFill>
+              </a:rPr>
+              <a:t>Change our filing rules and portal through the Rules of Practice review already under way</a:t>
+            </a:r>
+            <a:endParaRPr lang="en-US" sz="1700" dirty="0"/>
+          </a:p>
+          <a:p>
+            <a:pPr marL="342900" indent="-342900">
+              <a:spcAft>
+                <a:spcPts val="600"/>
+              </a:spcAft>
+              <a:buSzPct val="100000"/>
+              <a:buChar char="•"/>
+            </a:pPr>
+            <a:r>
+              <a:rPr lang="en-US" sz="1700" dirty="0">
+                <a:solidFill>
+                  <a:schemeClr val="tx1"/>
+                </a:solidFill>
+              </a:rPr>
+              <a:t>Start now with two quick wins: the automatic upload check, and a privacy review of flawed redactions</a:t>
+            </a:r>
+            <a:endParaRPr lang="en-US" sz="1700" dirty="0"/>
+          </a:p>
+        </p:txBody>
+      </p:sp>
+      <p:sp>
+        <p:nvSpPr>
+          <p:cNvPr id="14" name="Text 12"/>
+          <p:cNvSpPr txBox="1"/>
+          <p:nvPr/>
+        </p:nvSpPr>
+        <p:spPr>
+          <a:xfrm>
+            <a:off x="548640" y="6263640"/>
+            <a:ext cx="10424160" cy="365760"/>
+          </a:xfrm>
+          <a:prstGeom prst="rect">
+            <a:avLst/>
+          </a:prstGeom>
+          <a:noFill/>
+          <a:ln/>
+        </p:spPr>
+        <p:txBody>
+          <a:bodyPr wrap="square" lIns="0" tIns="0" rIns="0" bIns="0" rtlCol="0" anchor="ctr"/>
+          <a:lstStyle/>
+          <a:p>
+            <a:pPr indent="0" marL="0">
+              <a:buNone/>
+            </a:pPr>
+            <a:r>
+              <a:rPr lang="en-US" sz="1200" i="1" dirty="0">
+                <a:solidFill>
+                  <a:schemeClr val="bg2"/>
+                </a:solidFill>
+              </a:rPr>
+              <a:t>“Agentic AI is not primarily a technology challenge.”  — UK Local Government Association, 2026</a:t>
+            </a:r>
+            <a:endParaRPr lang="en-US" sz="1200" dirty="0"/>
+          </a:p>
+        </p:txBody>
+      </p:sp>
+      <p:sp>
+        <p:nvSpPr>
+          <p:cNvPr id="25" name="Slide Number Placeholder 0"/>
+          <p:cNvSpPr>
+            <a:spLocks noGrp="1"/>
+          </p:cNvSpPr>
+          <p:nvPr>
+            <p:ph type="sldNum" sz="quarter" idx="4294967295"/>
+          </p:nvPr>
+        </p:nvSpPr>
+        <p:spPr>
+          <a:xfrm>
+            <a:off x="11155680" y="6400800"/>
+            <a:ext cx="457200" cy="274320"/>
+          </a:xfrm>
+          <a:prstGeom prst="rect">
+            <a:avLst/>
+          </a:prstGeom>
+          <a:extLst>
+            <a:ext uri="{C572A759-6A51-4108-AA02-DFA0A04FC94B}">
+              <ma14:wrappingTextBoxFlag xmlns:ma14="http://schemas.microsoft.com/office/mac/drawingml/2011/main" val="0"/>
+            </a:ext>
+          </a:extLst>
+        </p:spPr>
+        <p:txBody>
+          <a:bodyPr/>
+          <a:lstStyle>
+            <a:lvl1pPr>
+              <a:defRPr sz="1000">
+                <a:solidFill>
+                  <a:schemeClr val="bg2"/>
+                </a:solidFill>
+              </a:defRPr>
+            </a:lvl1pPr>
+          </a:lstStyle>
+          <a:p>
+            <a:pPr algn="r"/>
+            <a:fld id="{F7021451-1387-4CA6-816F-3879F97B5CBC}" type="slidenum">
+              <a:rPr b="0" lang="en-US"/>
+              <a:t>13</a:t>
             </a:fld>
             <a:endParaRPr lang="en-US"/>
           </a:p>
@@ -5920,7 +7197,7 @@
         </p:nvSpPr>
         <p:spPr>
           <a:xfrm>
-            <a:off x="548640" y="4297680"/>
+            <a:off x="548640" y="4114800"/>
             <a:ext cx="11064240" cy="1097280"/>
           </a:xfrm>
           <a:prstGeom prst="rect">
@@ -5945,6 +7222,78 @@
               <a:t>AI can only be as good as what it reads. Today, a quarter of our record would give it pictures to guess at, or text that is wrong.</a:t>
             </a:r>
             <a:endParaRPr lang="en-US" sz="2200" dirty="0"/>
+          </a:p>
+        </p:txBody>
+      </p:sp>
+      <p:sp>
+        <p:nvSpPr>
+          <p:cNvPr id="6" name="Text 4"/>
+          <p:cNvSpPr txBox="1"/>
+          <p:nvPr/>
+        </p:nvSpPr>
+        <p:spPr>
+          <a:xfrm>
+            <a:off x="548640" y="5349240"/>
+            <a:ext cx="11064240" cy="685800"/>
+          </a:xfrm>
+          <a:prstGeom prst="rect">
+            <a:avLst/>
+          </a:prstGeom>
+          <a:noFill/>
+          <a:ln/>
+        </p:spPr>
+        <p:txBody>
+          <a:bodyPr wrap="square" lIns="0" tIns="0" rIns="0" bIns="0" rtlCol="0" anchor="t"/>
+          <a:lstStyle/>
+          <a:p>
+            <a:pPr indent="0" marL="0">
+              <a:buNone/>
+            </a:pPr>
+            <a:r>
+              <a:rPr lang="en-US" sz="1600" i="1" dirty="0">
+                <a:solidFill>
+                  <a:schemeClr val="bg2"/>
+                </a:solidFill>
+              </a:rPr>
+              <a:t>“AI will not fix unclear processes, weak ownership or poor-quality data. In many cases, it will make those weaknesses more visible.”</a:t>
+            </a:r>
+            <a:endParaRPr lang="en-US" sz="1600" dirty="0"/>
+          </a:p>
+        </p:txBody>
+      </p:sp>
+      <p:sp>
+        <p:nvSpPr>
+          <p:cNvPr id="7" name="Text 5"/>
+          <p:cNvSpPr txBox="1"/>
+          <p:nvPr/>
+        </p:nvSpPr>
+        <p:spPr>
+          <a:xfrm>
+            <a:off x="548640" y="6035040"/>
+            <a:ext cx="10058400" cy="320040"/>
+          </a:xfrm>
+          <a:prstGeom prst="rect">
+            <a:avLst/>
+          </a:prstGeom>
+          <a:noFill/>
+          <a:ln/>
+        </p:spPr>
+        <p:txBody>
+          <a:bodyPr wrap="square" lIns="0" tIns="0" rIns="0" bIns="0" rtlCol="0" anchor="ctr"/>
+          <a:lstStyle/>
+          <a:p>
+            <a:pPr indent="0" marL="0">
+              <a:buNone/>
+            </a:pPr>
+            <a:r>
+              <a:rPr lang="en-US" sz="1200" dirty="0">
+                <a:solidFill>
+                  <a:schemeClr val="accent5"/>
+                </a:solidFill>
+              </a:rPr>
+              <a:t>— UK Local Government Association, A playbook for agentic AI (2026)</a:t>
+            </a:r>
+            <a:endParaRPr lang="en-US" sz="1200" dirty="0"/>
           </a:p>
         </p:txBody>
       </p:sp>

</xml_diff>

<commit_message>
docs: executive deck cites its sources; SOURCES.md with every link
A Sources slide (14) names the record, the UK LGA agentic AI playbook, the
joint cyber guidance (with the Canadian Centre for Cyber Security), the
federal AI Strategy, the BC Energy Regulator tender, AER OneStop and the
CER's own rules and plans; SOURCES.md gives the links and the estimates.
</commit_message>
<xml_diff>
--- a/docs/ceo-deck/Getting our filings ready for AI.pptx
+++ b/docs/ceo-deck/Getting our filings ready for AI.pptx
@@ -18,9 +18,10 @@
     <p:sldId id="266" r:id="rId12"/>
     <p:sldId id="267" r:id="rId13"/>
     <p:sldId id="268" r:id="rId14"/>
+    <p:sldId id="269" r:id="rId15"/>
   </p:sldIdLst>
   <p:notesMasterIdLst>
-    <p:notesMasterId r:id="rId15"/>
+    <p:notesMasterId r:id="rId16"/>
   </p:notesMasterIdLst>
   <p:sldSz cx="12192000" cy="6858000"/>
   <p:notesSz cx="6858000" cy="12192000"/>
@@ -119,14 +120,14 @@
   <p:extLst>
     <p:ext uri="{521415D9-36F7-43E2-AB2F-B90AF26B5E84}">
       <p14:sectionLst xmlns:p14="http://schemas.microsoft.com/office/powerpoint/2010/main">
-        <p14:section name="The record" id="{a197ede7-47a3-55fe-98ef-ac215573e20d}">
+        <p14:section name="The record" id="{9917285b-4e8a-f238-c225-27a6b6e30bff}">
           <p14:sldIdLst>
             <p14:sldId id="256"/>
             <p14:sldId id="257"/>
             <p14:sldId id="258"/>
           </p14:sldIdLst>
         </p14:section>
-        <p14:section name="The problems" id="{d85d5ecd-789f-e77b-3b01-c35fd32a82ec}">
+        <p14:section name="The problems" id="{6447ab15-4ccd-3f3d-516d-9708622eee4d}">
           <p14:sldIdLst>
             <p14:sldId id="259"/>
             <p14:sldId id="260"/>
@@ -135,7 +136,7 @@
             <p14:sldId id="263"/>
           </p14:sldIdLst>
         </p14:section>
-        <p14:section name="The solution" id="{3a02df9b-f853-01bf-7581-4ce91f1a5b81}">
+        <p14:section name="The solution" id="{62c768b5-7f7a-198c-dff8-882491674b5d}">
           <p14:sldIdLst>
             <p14:sldId id="264"/>
             <p14:sldId id="265"/>
@@ -143,9 +144,14 @@
             <p14:sldId id="267"/>
           </p14:sldIdLst>
         </p14:section>
-        <p14:section name="Making change happen" id="{0d751de8-63fd-82d1-4f45-ab9c56eb515b}">
+        <p14:section name="Making change happen" id="{d7248157-e542-05ce-9832-51e670886962}">
           <p14:sldIdLst>
             <p14:sldId id="268"/>
+          </p14:sldIdLst>
+        </p14:section>
+        <p14:section name="Sources" id="{b7370835-5e41-6e39-692e-2e68a70aaffb}">
+          <p14:sldIdLst>
+            <p14:sldId id="269"/>
           </p14:sldIdLst>
         </p14:section>
       </p14:sectionLst>
@@ -928,6 +934,94 @@
             <a:fld id="{F7021451-1387-4CA6-816F-3879F97B5CBC}" type="slidenum">
               <a:rPr lang="en-US"/>
               <a:t>13</a:t>
+            </a:fld>
+            <a:endParaRPr lang="en-US"/>
+          </a:p>
+        </p:txBody>
+      </p:sp>
+    </p:spTree>
+    <p:extLst>
+      <p:ext uri="{BB962C8B-B14F-4D97-AF65-F5344CB8AC3E}">
+        <p14:creationId xmlns:p14="http://schemas.microsoft.com/office/powerpoint/2010/main" val="1024086991"/>
+      </p:ext>
+    </p:extLst>
+  </p:cSld>
+  <p:clrMapOvr>
+    <a:masterClrMapping/>
+  </p:clrMapOvr>
+</p:notes>
+</file>
+
+<file path=ppt/notesSlides/notesSlide14.xml><?xml version="1.0" encoding="utf-8"?>
+<p:notes xmlns:a="http://schemas.openxmlformats.org/drawingml/2006/main" xmlns:r="http://schemas.openxmlformats.org/officeDocument/2006/relationships" xmlns:p="http://schemas.openxmlformats.org/presentationml/2006/main">
+  <p:cSld>
+    <p:spTree>
+      <p:nvGrpSpPr>
+        <p:cNvPr id="1" name=""/>
+        <p:cNvGrpSpPr/>
+        <p:nvPr/>
+      </p:nvGrpSpPr>
+      <p:grpSpPr>
+        <a:xfrm>
+          <a:off x="0" y="0"/>
+          <a:ext cx="0" cy="0"/>
+          <a:chOff x="0" y="0"/>
+          <a:chExt cx="0" cy="0"/>
+        </a:xfrm>
+      </p:grpSpPr>
+      <p:sp>
+        <p:nvSpPr>
+          <p:cNvPr id="2" name="Slide Image Placeholder 1"/>
+          <p:cNvSpPr>
+            <a:spLocks noGrp="1" noRot="1" noChangeAspect="1"/>
+          </p:cNvSpPr>
+          <p:nvPr>
+            <p:ph type="sldImg"/>
+          </p:nvPr>
+        </p:nvSpPr>
+        <p:spPr/>
+      </p:sp>
+      <p:sp>
+        <p:nvSpPr>
+          <p:cNvPr id="3" name="Notes Placeholder 2"/>
+          <p:cNvSpPr>
+            <a:spLocks noGrp="1"/>
+          </p:cNvSpPr>
+          <p:nvPr>
+            <p:ph type="body" idx="1"/>
+          </p:nvPr>
+        </p:nvSpPr>
+        <p:spPr/>
+        <p:txBody>
+          <a:bodyPr/>
+          <a:lstStyle/>
+          <a:p>
+            <a:r>
+              <a:rPr lang="en-US" dirty="0"/>
+              <a:t>Sources for the figures and quotations in this presentation. Figures about the CER's record are counts from reading every PDF in REGDOCS (October 2026). Two figures are estimates: about 75 years assumes two minutes to read a page and 1,600 working hours a year; 13,000 novels assumes about 90,000 words a novel.</a:t>
+            </a:r>
+            <a:endParaRPr lang="en-US" dirty="0"/>
+          </a:p>
+        </p:txBody>
+      </p:sp>
+      <p:sp>
+        <p:nvSpPr>
+          <p:cNvPr id="4" name="Slide Number Placeholder 3"/>
+          <p:cNvSpPr>
+            <a:spLocks noGrp="1"/>
+          </p:cNvSpPr>
+          <p:nvPr>
+            <p:ph type="sldNum" sz="quarter" idx="10"/>
+          </p:nvPr>
+        </p:nvSpPr>
+        <p:spPr/>
+        <p:txBody>
+          <a:bodyPr/>
+          <a:lstStyle/>
+          <a:p>
+            <a:fld id="{F7021451-1387-4CA6-816F-3879F97B5CBC}" type="slidenum">
+              <a:rPr lang="en-US"/>
+              <a:t>14</a:t>
             </a:fld>
             <a:endParaRPr lang="en-US"/>
           </a:p>
@@ -6019,6 +6113,618 @@
             <a:fld id="{F7021451-1387-4CA6-816F-3879F97B5CBC}" type="slidenum">
               <a:rPr b="0" lang="en-US"/>
               <a:t>13</a:t>
+            </a:fld>
+            <a:endParaRPr lang="en-US"/>
+          </a:p>
+        </p:txBody>
+      </p:sp>
+    </p:spTree>
+  </p:cSld>
+  <p:clrMapOvr>
+    <a:masterClrMapping/>
+  </p:clrMapOvr>
+</p:sld>
+</file>
+
+<file path=ppt/slides/slide14.xml><?xml version="1.0" encoding="utf-8"?>
+<p:sld xmlns:a="http://schemas.openxmlformats.org/drawingml/2006/main" xmlns:r="http://schemas.openxmlformats.org/officeDocument/2006/relationships" xmlns:p="http://schemas.openxmlformats.org/presentationml/2006/main">
+  <p:cSld name="Slide 14">
+    <p:spTree>
+      <p:nvGrpSpPr>
+        <p:cNvPr id="1" name=""/>
+        <p:cNvGrpSpPr/>
+        <p:nvPr/>
+      </p:nvGrpSpPr>
+      <p:grpSpPr>
+        <a:xfrm>
+          <a:off x="0" y="0"/>
+          <a:ext cx="0" cy="0"/>
+          <a:chOff x="0" y="0"/>
+          <a:chExt cx="0" cy="0"/>
+        </a:xfrm>
+      </p:grpSpPr>
+      <p:sp>
+        <p:nvSpPr>
+          <p:cNvPr id="2" name="Text 0"/>
+          <p:cNvSpPr/>
+          <p:nvPr>
+            <p:ph idx="100" type="title" hasCustomPrompt="1"/>
+          </p:nvPr>
+        </p:nvSpPr>
+        <p:spPr>
+          <a:xfrm>
+            <a:off x="548640" y="365760"/>
+            <a:ext cx="11064240" cy="822960"/>
+          </a:xfrm>
+          <a:prstGeom prst="rect">
+            <a:avLst/>
+          </a:prstGeom>
+          <a:noFill/>
+          <a:ln/>
+        </p:spPr>
+        <p:txBody>
+          <a:bodyPr wrap="square" lIns="0" tIns="0" rIns="0" bIns="0" rtlCol="0" anchor="ctr"/>
+          <a:lstStyle/>
+          <a:p>
+            <a:pPr indent="0" marL="0">
+              <a:buNone/>
+            </a:pPr>
+            <a:r>
+              <a:rPr lang="en-US" sz="3400" b="1" dirty="0">
+                <a:solidFill>
+                  <a:schemeClr val="tx2"/>
+                </a:solidFill>
+              </a:rPr>
+              <a:t>Sources</a:t>
+            </a:r>
+            <a:endParaRPr lang="en-US" sz="3400" dirty="0"/>
+          </a:p>
+        </p:txBody>
+      </p:sp>
+      <p:sp>
+        <p:nvSpPr>
+          <p:cNvPr id="3" name="Text 1"/>
+          <p:cNvSpPr txBox="1"/>
+          <p:nvPr/>
+        </p:nvSpPr>
+        <p:spPr>
+          <a:xfrm>
+            <a:off x="548640" y="1371600"/>
+            <a:ext cx="3291840" cy="640080"/>
+          </a:xfrm>
+          <a:prstGeom prst="rect">
+            <a:avLst/>
+          </a:prstGeom>
+          <a:noFill/>
+          <a:ln/>
+        </p:spPr>
+        <p:txBody>
+          <a:bodyPr wrap="square" lIns="0" tIns="0" rIns="0" bIns="0" rtlCol="0" anchor="t"/>
+          <a:lstStyle/>
+          <a:p>
+            <a:pPr indent="0" marL="0">
+              <a:buNone/>
+            </a:pPr>
+            <a:r>
+              <a:rPr lang="en-US" sz="1300" b="1" dirty="0">
+                <a:solidFill>
+                  <a:schemeClr val="tx2"/>
+                </a:solidFill>
+              </a:rPr>
+              <a:t>Our record</a:t>
+            </a:r>
+            <a:endParaRPr lang="en-US" sz="1300" dirty="0"/>
+          </a:p>
+        </p:txBody>
+      </p:sp>
+      <p:sp>
+        <p:nvSpPr>
+          <p:cNvPr id="4" name="Text 2"/>
+          <p:cNvSpPr txBox="1"/>
+          <p:nvPr/>
+        </p:nvSpPr>
+        <p:spPr>
+          <a:xfrm>
+            <a:off x="4023360" y="1371600"/>
+            <a:ext cx="7589520" cy="640080"/>
+          </a:xfrm>
+          <a:prstGeom prst="rect">
+            <a:avLst/>
+          </a:prstGeom>
+          <a:noFill/>
+          <a:ln/>
+        </p:spPr>
+        <p:txBody>
+          <a:bodyPr wrap="square" lIns="0" tIns="0" rIns="0" bIns="0" rtlCol="0" anchor="t"/>
+          <a:lstStyle/>
+          <a:p>
+            <a:pPr indent="0" marL="0">
+              <a:buNone/>
+            </a:pPr>
+            <a:r>
+              <a:rPr lang="en-US" sz="1300" dirty="0">
+                <a:solidFill>
+                  <a:schemeClr val="tx1"/>
+                </a:solidFill>
+              </a:rPr>
+              <a:t>Every PDF in REGDOCS read page by page, October 2026: 269,025 documents. Reports and code in the cer-regdocs5 project (census, integrity pass, filing guidance).</a:t>
+            </a:r>
+            <a:endParaRPr lang="en-US" sz="1300" dirty="0"/>
+          </a:p>
+        </p:txBody>
+      </p:sp>
+      <p:sp>
+        <p:nvSpPr>
+          <p:cNvPr id="5" name="Text 3"/>
+          <p:cNvSpPr txBox="1"/>
+          <p:nvPr/>
+        </p:nvSpPr>
+        <p:spPr>
+          <a:xfrm>
+            <a:off x="548640" y="2057400"/>
+            <a:ext cx="3291840" cy="640080"/>
+          </a:xfrm>
+          <a:prstGeom prst="rect">
+            <a:avLst/>
+          </a:prstGeom>
+          <a:noFill/>
+          <a:ln/>
+        </p:spPr>
+        <p:txBody>
+          <a:bodyPr wrap="square" lIns="0" tIns="0" rIns="0" bIns="0" rtlCol="0" anchor="t"/>
+          <a:lstStyle/>
+          <a:p>
+            <a:pPr indent="0" marL="0">
+              <a:buNone/>
+            </a:pPr>
+            <a:r>
+              <a:rPr lang="en-US" sz="1300" b="1" dirty="0">
+                <a:solidFill>
+                  <a:schemeClr val="tx2"/>
+                </a:solidFill>
+              </a:rPr>
+              <a:t>UK Local Government Association</a:t>
+            </a:r>
+            <a:endParaRPr lang="en-US" sz="1300" dirty="0"/>
+          </a:p>
+        </p:txBody>
+      </p:sp>
+      <p:sp>
+        <p:nvSpPr>
+          <p:cNvPr id="6" name="Text 4"/>
+          <p:cNvSpPr txBox="1"/>
+          <p:nvPr/>
+        </p:nvSpPr>
+        <p:spPr>
+          <a:xfrm>
+            <a:off x="4023360" y="2057400"/>
+            <a:ext cx="7589520" cy="640080"/>
+          </a:xfrm>
+          <a:prstGeom prst="rect">
+            <a:avLst/>
+          </a:prstGeom>
+          <a:noFill/>
+          <a:ln/>
+        </p:spPr>
+        <p:txBody>
+          <a:bodyPr wrap="square" lIns="0" tIns="0" rIns="0" bIns="0" rtlCol="0" anchor="t"/>
+          <a:lstStyle/>
+          <a:p>
+            <a:pPr indent="0" marL="0">
+              <a:buNone/>
+            </a:pPr>
+            <a:r>
+              <a:rPr lang="en-US" sz="1300" dirty="0">
+                <a:solidFill>
+                  <a:schemeClr val="tx1"/>
+                </a:solidFill>
+              </a:rPr>
+              <a:t>A playbook for agentic AI in local government, 9 October 2026. local.gov.uk/publications/playbook-agentic-ai-local-government</a:t>
+            </a:r>
+            <a:endParaRPr lang="en-US" sz="1300" dirty="0"/>
+          </a:p>
+        </p:txBody>
+      </p:sp>
+      <p:sp>
+        <p:nvSpPr>
+          <p:cNvPr id="7" name="Text 5"/>
+          <p:cNvSpPr txBox="1"/>
+          <p:nvPr/>
+        </p:nvSpPr>
+        <p:spPr>
+          <a:xfrm>
+            <a:off x="548640" y="2743200"/>
+            <a:ext cx="3291840" cy="640080"/>
+          </a:xfrm>
+          <a:prstGeom prst="rect">
+            <a:avLst/>
+          </a:prstGeom>
+          <a:noFill/>
+          <a:ln/>
+        </p:spPr>
+        <p:txBody>
+          <a:bodyPr wrap="square" lIns="0" tIns="0" rIns="0" bIns="0" rtlCol="0" anchor="t"/>
+          <a:lstStyle/>
+          <a:p>
+            <a:pPr indent="0" marL="0">
+              <a:buNone/>
+            </a:pPr>
+            <a:r>
+              <a:rPr lang="en-US" sz="1300" b="1" dirty="0">
+                <a:solidFill>
+                  <a:schemeClr val="tx2"/>
+                </a:solidFill>
+              </a:rPr>
+              <a:t>Cyber security agencies incl. the Canadian Centre for Cyber Security</a:t>
+            </a:r>
+            <a:endParaRPr lang="en-US" sz="1300" dirty="0"/>
+          </a:p>
+        </p:txBody>
+      </p:sp>
+      <p:sp>
+        <p:nvSpPr>
+          <p:cNvPr id="8" name="Text 6"/>
+          <p:cNvSpPr txBox="1"/>
+          <p:nvPr/>
+        </p:nvSpPr>
+        <p:spPr>
+          <a:xfrm>
+            <a:off x="4023360" y="2743200"/>
+            <a:ext cx="7589520" cy="640080"/>
+          </a:xfrm>
+          <a:prstGeom prst="rect">
+            <a:avLst/>
+          </a:prstGeom>
+          <a:noFill/>
+          <a:ln/>
+        </p:spPr>
+        <p:txBody>
+          <a:bodyPr wrap="square" lIns="0" tIns="0" rIns="0" bIns="0" rtlCol="0" anchor="t"/>
+          <a:lstStyle/>
+          <a:p>
+            <a:pPr indent="0" marL="0">
+              <a:buNone/>
+            </a:pPr>
+            <a:r>
+              <a:rPr lang="en-US" sz="1300" dirty="0">
+                <a:solidFill>
+                  <a:schemeClr val="tx1"/>
+                </a:solidFill>
+              </a:rPr>
+              <a:t>Careful adoption of agentic AI services, 1 May 2026. cyber.gov.au (secure design: artificial intelligence)</a:t>
+            </a:r>
+            <a:endParaRPr lang="en-US" sz="1300" dirty="0"/>
+          </a:p>
+        </p:txBody>
+      </p:sp>
+      <p:sp>
+        <p:nvSpPr>
+          <p:cNvPr id="9" name="Text 7"/>
+          <p:cNvSpPr txBox="1"/>
+          <p:nvPr/>
+        </p:nvSpPr>
+        <p:spPr>
+          <a:xfrm>
+            <a:off x="548640" y="3429000"/>
+            <a:ext cx="3291840" cy="640080"/>
+          </a:xfrm>
+          <a:prstGeom prst="rect">
+            <a:avLst/>
+          </a:prstGeom>
+          <a:noFill/>
+          <a:ln/>
+        </p:spPr>
+        <p:txBody>
+          <a:bodyPr wrap="square" lIns="0" tIns="0" rIns="0" bIns="0" rtlCol="0" anchor="t"/>
+          <a:lstStyle/>
+          <a:p>
+            <a:pPr indent="0" marL="0">
+              <a:buNone/>
+            </a:pPr>
+            <a:r>
+              <a:rPr lang="en-US" sz="1300" b="1" dirty="0">
+                <a:solidFill>
+                  <a:schemeClr val="tx2"/>
+                </a:solidFill>
+              </a:rPr>
+              <a:t>Government of Canada</a:t>
+            </a:r>
+            <a:endParaRPr lang="en-US" sz="1300" dirty="0"/>
+          </a:p>
+        </p:txBody>
+      </p:sp>
+      <p:sp>
+        <p:nvSpPr>
+          <p:cNvPr id="10" name="Text 8"/>
+          <p:cNvSpPr txBox="1"/>
+          <p:nvPr/>
+        </p:nvSpPr>
+        <p:spPr>
+          <a:xfrm>
+            <a:off x="4023360" y="3429000"/>
+            <a:ext cx="7589520" cy="640080"/>
+          </a:xfrm>
+          <a:prstGeom prst="rect">
+            <a:avLst/>
+          </a:prstGeom>
+          <a:noFill/>
+          <a:ln/>
+        </p:spPr>
+        <p:txBody>
+          <a:bodyPr wrap="square" lIns="0" tIns="0" rIns="0" bIns="0" rtlCol="0" anchor="t"/>
+          <a:lstStyle/>
+          <a:p>
+            <a:pPr indent="0" marL="0">
+              <a:buNone/>
+            </a:pPr>
+            <a:r>
+              <a:rPr lang="en-US" sz="1300" dirty="0">
+                <a:solidFill>
+                  <a:schemeClr val="tx1"/>
+                </a:solidFill>
+              </a:rPr>
+              <a:t>AI Strategy for the Federal Public Service 2025–2027. canada.ca/en/government/system/digital-government/digital-government-innovations/responsible-use-ai</a:t>
+            </a:r>
+            <a:endParaRPr lang="en-US" sz="1300" dirty="0"/>
+          </a:p>
+        </p:txBody>
+      </p:sp>
+      <p:sp>
+        <p:nvSpPr>
+          <p:cNvPr id="11" name="Text 9"/>
+          <p:cNvSpPr txBox="1"/>
+          <p:nvPr/>
+        </p:nvSpPr>
+        <p:spPr>
+          <a:xfrm>
+            <a:off x="548640" y="4114800"/>
+            <a:ext cx="3291840" cy="640080"/>
+          </a:xfrm>
+          <a:prstGeom prst="rect">
+            <a:avLst/>
+          </a:prstGeom>
+          <a:noFill/>
+          <a:ln/>
+        </p:spPr>
+        <p:txBody>
+          <a:bodyPr wrap="square" lIns="0" tIns="0" rIns="0" bIns="0" rtlCol="0" anchor="t"/>
+          <a:lstStyle/>
+          <a:p>
+            <a:pPr indent="0" marL="0">
+              <a:buNone/>
+            </a:pPr>
+            <a:r>
+              <a:rPr lang="en-US" sz="1300" b="1" dirty="0">
+                <a:solidFill>
+                  <a:schemeClr val="tx2"/>
+                </a:solidFill>
+              </a:rPr>
+              <a:t>BC Energy Regulator</a:t>
+            </a:r>
+            <a:endParaRPr lang="en-US" sz="1300" dirty="0"/>
+          </a:p>
+        </p:txBody>
+      </p:sp>
+      <p:sp>
+        <p:nvSpPr>
+          <p:cNvPr id="12" name="Text 10"/>
+          <p:cNvSpPr txBox="1"/>
+          <p:nvPr/>
+        </p:nvSpPr>
+        <p:spPr>
+          <a:xfrm>
+            <a:off x="4023360" y="4114800"/>
+            <a:ext cx="7589520" cy="640080"/>
+          </a:xfrm>
+          <a:prstGeom prst="rect">
+            <a:avLst/>
+          </a:prstGeom>
+          <a:noFill/>
+          <a:ln/>
+        </p:spPr>
+        <p:txBody>
+          <a:bodyPr wrap="square" lIns="0" tIns="0" rIns="0" bIns="0" rtlCol="0" anchor="t"/>
+          <a:lstStyle/>
+          <a:p>
+            <a:pPr indent="0" marL="0">
+              <a:buNone/>
+            </a:pPr>
+            <a:r>
+              <a:rPr lang="en-US" sz="1300" dirty="0">
+                <a:solidFill>
+                  <a:schemeClr val="tx1"/>
+                </a:solidFill>
+              </a:rPr>
+              <a:t>AI enhancement services for permit automation, CanadaBuys tender BC231865, July 2026.</a:t>
+            </a:r>
+            <a:endParaRPr lang="en-US" sz="1300" dirty="0"/>
+          </a:p>
+        </p:txBody>
+      </p:sp>
+      <p:sp>
+        <p:nvSpPr>
+          <p:cNvPr id="13" name="Text 11"/>
+          <p:cNvSpPr txBox="1"/>
+          <p:nvPr/>
+        </p:nvSpPr>
+        <p:spPr>
+          <a:xfrm>
+            <a:off x="548640" y="4800600"/>
+            <a:ext cx="3291840" cy="640080"/>
+          </a:xfrm>
+          <a:prstGeom prst="rect">
+            <a:avLst/>
+          </a:prstGeom>
+          <a:noFill/>
+          <a:ln/>
+        </p:spPr>
+        <p:txBody>
+          <a:bodyPr wrap="square" lIns="0" tIns="0" rIns="0" bIns="0" rtlCol="0" anchor="t"/>
+          <a:lstStyle/>
+          <a:p>
+            <a:pPr indent="0" marL="0">
+              <a:buNone/>
+            </a:pPr>
+            <a:r>
+              <a:rPr lang="en-US" sz="1300" b="1" dirty="0">
+                <a:solidFill>
+                  <a:schemeClr val="tx2"/>
+                </a:solidFill>
+              </a:rPr>
+              <a:t>Alberta Energy Regulator</a:t>
+            </a:r>
+            <a:endParaRPr lang="en-US" sz="1300" dirty="0"/>
+          </a:p>
+        </p:txBody>
+      </p:sp>
+      <p:sp>
+        <p:nvSpPr>
+          <p:cNvPr id="14" name="Text 12"/>
+          <p:cNvSpPr txBox="1"/>
+          <p:nvPr/>
+        </p:nvSpPr>
+        <p:spPr>
+          <a:xfrm>
+            <a:off x="4023360" y="4800600"/>
+            <a:ext cx="7589520" cy="640080"/>
+          </a:xfrm>
+          <a:prstGeom prst="rect">
+            <a:avLst/>
+          </a:prstGeom>
+          <a:noFill/>
+          <a:ln/>
+        </p:spPr>
+        <p:txBody>
+          <a:bodyPr wrap="square" lIns="0" tIns="0" rIns="0" bIns="0" rtlCol="0" anchor="t"/>
+          <a:lstStyle/>
+          <a:p>
+            <a:pPr indent="0" marL="0">
+              <a:buNone/>
+            </a:pPr>
+            <a:r>
+              <a:rPr lang="en-US" sz="1300" dirty="0">
+                <a:solidFill>
+                  <a:schemeClr val="tx1"/>
+                </a:solidFill>
+              </a:rPr>
+              <a:t>OneStop results as reported by IT World Canada (itbusiness.ca), citing the AER 2017/18 annual report.</a:t>
+            </a:r>
+            <a:endParaRPr lang="en-US" sz="1300" dirty="0"/>
+          </a:p>
+        </p:txBody>
+      </p:sp>
+      <p:sp>
+        <p:nvSpPr>
+          <p:cNvPr id="15" name="Text 13"/>
+          <p:cNvSpPr txBox="1"/>
+          <p:nvPr/>
+        </p:nvSpPr>
+        <p:spPr>
+          <a:xfrm>
+            <a:off x="548640" y="5486400"/>
+            <a:ext cx="3291840" cy="640080"/>
+          </a:xfrm>
+          <a:prstGeom prst="rect">
+            <a:avLst/>
+          </a:prstGeom>
+          <a:noFill/>
+          <a:ln/>
+        </p:spPr>
+        <p:txBody>
+          <a:bodyPr wrap="square" lIns="0" tIns="0" rIns="0" bIns="0" rtlCol="0" anchor="t"/>
+          <a:lstStyle/>
+          <a:p>
+            <a:pPr indent="0" marL="0">
+              <a:buNone/>
+            </a:pPr>
+            <a:r>
+              <a:rPr lang="en-US" sz="1300" b="1" dirty="0">
+                <a:solidFill>
+                  <a:schemeClr val="tx2"/>
+                </a:solidFill>
+              </a:rPr>
+              <a:t>Canada Energy Regulator</a:t>
+            </a:r>
+            <a:endParaRPr lang="en-US" sz="1300" dirty="0"/>
+          </a:p>
+        </p:txBody>
+      </p:sp>
+      <p:sp>
+        <p:nvSpPr>
+          <p:cNvPr id="16" name="Text 14"/>
+          <p:cNvSpPr txBox="1"/>
+          <p:nvPr/>
+        </p:nvSpPr>
+        <p:spPr>
+          <a:xfrm>
+            <a:off x="4023360" y="5486400"/>
+            <a:ext cx="7589520" cy="640080"/>
+          </a:xfrm>
+          <a:prstGeom prst="rect">
+            <a:avLst/>
+          </a:prstGeom>
+          <a:noFill/>
+          <a:ln/>
+        </p:spPr>
+        <p:txBody>
+          <a:bodyPr wrap="square" lIns="0" tIns="0" rIns="0" bIns="0" rtlCol="0" anchor="t"/>
+          <a:lstStyle/>
+          <a:p>
+            <a:pPr indent="0" marL="0">
+              <a:buNone/>
+            </a:pPr>
+            <a:r>
+              <a:rPr lang="en-US" sz="1300" dirty="0">
+                <a:solidFill>
+                  <a:schemeClr val="tx1"/>
+                </a:solidFill>
+              </a:rPr>
+              <a:t>Filer’s Guide to Electronic Submission (June 2025); Filing Manual, chapter 1 (July 2025); Strategic Plan 2024–2027; Rules of Practice and Procedure review (2024–).</a:t>
+            </a:r>
+            <a:endParaRPr lang="en-US" sz="1300" dirty="0"/>
+          </a:p>
+        </p:txBody>
+      </p:sp>
+      <p:sp>
+        <p:nvSpPr>
+          <p:cNvPr id="25" name="Slide Number Placeholder 0"/>
+          <p:cNvSpPr>
+            <a:spLocks noGrp="1"/>
+          </p:cNvSpPr>
+          <p:nvPr>
+            <p:ph type="sldNum" sz="quarter" idx="4294967295"/>
+          </p:nvPr>
+        </p:nvSpPr>
+        <p:spPr>
+          <a:xfrm>
+            <a:off x="11155680" y="6400800"/>
+            <a:ext cx="457200" cy="274320"/>
+          </a:xfrm>
+          <a:prstGeom prst="rect">
+            <a:avLst/>
+          </a:prstGeom>
+          <a:extLst>
+            <a:ext uri="{C572A759-6A51-4108-AA02-DFA0A04FC94B}">
+              <ma14:wrappingTextBoxFlag xmlns:ma14="http://schemas.microsoft.com/office/mac/drawingml/2011/main" val="0"/>
+            </a:ext>
+          </a:extLst>
+        </p:spPr>
+        <p:txBody>
+          <a:bodyPr/>
+          <a:lstStyle>
+            <a:lvl1pPr>
+              <a:defRPr sz="1000">
+                <a:solidFill>
+                  <a:schemeClr val="accent3"/>
+                </a:solidFill>
+              </a:defRPr>
+            </a:lvl1pPr>
+          </a:lstStyle>
+          <a:p>
+            <a:pPr algn="r"/>
+            <a:fld id="{F7021451-1387-4CA6-816F-3879F97B5CBC}" type="slidenum">
+              <a:rPr b="0" lang="en-US"/>
+              <a:t>14</a:t>
             </a:fld>
             <a:endParaRPr lang="en-US"/>
           </a:p>

</xml_diff>